<commit_message>
docs(portfolio): PostgreSQL·Oracle Cloud 전환을 문서·사이트·슬라이드에 반영
문서(md→docx), 소개 사이트, 발표 슬라이드의 DB·배포·테스트 수치를 096~099 기준으로
고친다. 문서에 "7.5 SQLite → PostgreSQL 전환" 사례를, 사이트에 배포 구조도와 전환
카드를, 슬라이드에 "운영 준비" 한 장을 추가한다. 사이트의 모든 코드 블록이 줄바꿈 없이
뭉쳐 보이던 기존 CSS 버그와, docx 에서 굵게 안의 인라인 코드 백틱이 그대로 찍히던
변환기 버그도 고친다.

상세 기록: docs/commits/100-portfolio-postgres-oracle.md

Co-Authored-By: Claude Opus 5.5 <noreply@anthropic.com>
</commit_message>
<xml_diff>
--- a/portfolio/VidShare-포트폴리오.pptx
+++ b/portfolio/VidShare-포트폴리오.pptx
@@ -28,6 +28,7 @@
     <p:sldId id="276" r:id="rId27"/>
     <p:sldId id="277" r:id="rId28"/>
     <p:sldId id="278" r:id="rId29"/>
+    <p:sldId id="279" r:id="rId30"/>
   </p:sldIdLst>
   <p:sldSz cx="12191695" cy="6858000" type="screen4x3"/>
   <p:notesSz cx="6858000" cy="9144000"/>
@@ -3367,7 +3368,7 @@
                 <a:latin typeface="맑은 고딕"/>
                 <a:ea typeface="맑은 고딕"/>
               </a:rPr>
-              <a:t>풀스택 개인 프로젝트 · 2026.08 – 2026.09</a:t>
+              <a:t>풀스택 개인 프로젝트 · 2026.08 – 2026.10</a:t>
             </a:r>
           </a:p>
         </p:txBody>
@@ -3953,7 +3954,7 @@
                 <a:latin typeface="맑은 고딕"/>
                 <a:ea typeface="맑은 고딕"/>
               </a:rPr>
-              <a:t>177</a:t>
+              <a:t>188</a:t>
             </a:r>
           </a:p>
         </p:txBody>
@@ -4081,7 +4082,7 @@
                 <a:latin typeface="맑은 고딕"/>
                 <a:ea typeface="맑은 고딕"/>
               </a:rPr>
-              <a:t>162+</a:t>
+              <a:t>177</a:t>
             </a:r>
           </a:p>
         </p:txBody>
@@ -10302,7 +10303,7 @@
         <p:spPr>
           <a:xfrm>
             <a:off x="4507992" y="2468880"/>
-            <a:ext cx="722376" cy="384048"/>
+            <a:ext cx="1106424" cy="384048"/>
           </a:xfrm>
           <a:prstGeom prst="roundRect">
             <a:avLst>
@@ -10344,7 +10345,7 @@
                 <a:latin typeface="맑은 고딕"/>
                 <a:ea typeface="맑은 고딕"/>
               </a:rPr>
-              <a:t>SQLite</a:t>
+              <a:t>PostgreSQL</a:t>
             </a:r>
           </a:p>
         </p:txBody>
@@ -10357,7 +10358,7 @@
         </p:nvSpPr>
         <p:spPr>
           <a:xfrm>
-            <a:off x="5340096" y="2468880"/>
+            <a:off x="5724144" y="2468880"/>
             <a:ext cx="1010412" cy="384048"/>
           </a:xfrm>
           <a:prstGeom prst="roundRect">
@@ -10413,7 +10414,7 @@
         </p:nvSpPr>
         <p:spPr>
           <a:xfrm>
-            <a:off x="6460236" y="2468880"/>
+            <a:off x="6844284" y="2468880"/>
             <a:ext cx="434340" cy="384048"/>
           </a:xfrm>
           <a:prstGeom prst="roundRect">
@@ -10760,7 +10761,7 @@
                 <a:latin typeface="맑은 고딕"/>
                 <a:ea typeface="맑은 고딕"/>
               </a:rPr>
-              <a:t>배포</a:t>
+              <a:t>배포·운영</a:t>
             </a:r>
           </a:p>
         </p:txBody>
@@ -10830,7 +10831,7 @@
         <p:spPr>
           <a:xfrm>
             <a:off x="4636007" y="4023360"/>
-            <a:ext cx="1778507" cy="384048"/>
+            <a:ext cx="1298448" cy="384048"/>
           </a:xfrm>
           <a:prstGeom prst="roundRect">
             <a:avLst>
@@ -10872,7 +10873,7 @@
                 <a:latin typeface="맑은 고딕"/>
                 <a:ea typeface="맑은 고딕"/>
               </a:rPr>
-              <a:t>Cloudflare Tunnel</a:t>
+              <a:t>Oracle Cloud</a:t>
             </a:r>
           </a:p>
         </p:txBody>
@@ -10885,8 +10886,8 @@
         </p:nvSpPr>
         <p:spPr>
           <a:xfrm>
-            <a:off x="6524242" y="4023360"/>
-            <a:ext cx="722376" cy="384048"/>
+            <a:off x="6044183" y="4023360"/>
+            <a:ext cx="1490472" cy="384048"/>
           </a:xfrm>
           <a:prstGeom prst="roundRect">
             <a:avLst>
@@ -10928,7 +10929,7 @@
                 <a:latin typeface="맑은 고딕"/>
                 <a:ea typeface="맑은 고딕"/>
               </a:rPr>
-              <a:t>GitHub</a:t>
+              <a:t>GitHub Actions</a:t>
             </a:r>
           </a:p>
         </p:txBody>
@@ -10978,7 +10979,7 @@
                 <a:latin typeface="맑은 고딕"/>
                 <a:ea typeface="맑은 고딕"/>
               </a:rPr>
-              <a:t>모두가 아는 인기 기술을 그대로 쓰기보다, 이 규모(개인 프로젝트, 3개 앱)에 맞는 것을 택했습니다. 예를 들어 SQLite는 설치 없이 파일 하나로 영속화되고, 동기 API라 트랜잭션 코드가 단순합니다.</a:t>
+              <a:t>모두가 아는 인기 기술을 그대로 쓰기보다, 이 규모(개인 프로젝트, 3개 앱)에 맞는 것을 택했습니다. 예를 들어 처음엔 설치가 필요 없는 SQLite 로 시작했고, 실제 서버에 올리기로 하면서 백업과 이력 관리가 되는 PostgreSQL 로 옮겼습니다.</a:t>
             </a:r>
           </a:p>
         </p:txBody>
@@ -12160,7 +12161,7 @@
                 <a:latin typeface="맑은 고딕"/>
                 <a:ea typeface="맑은 고딕"/>
               </a:rPr>
-              <a:t>무엇으로, 얼마나 만들었나</a:t>
+              <a:t>무엇으로, 얼마나, 어디에서 운영하나</a:t>
             </a:r>
           </a:p>
         </p:txBody>
@@ -12600,7 +12601,7 @@
                 <a:latin typeface="맑은 고딕"/>
                 <a:ea typeface="맑은 고딕"/>
               </a:rPr>
-              <a:t>15,700+</a:t>
+              <a:t>16,100+</a:t>
             </a:r>
           </a:p>
         </p:txBody>
@@ -13112,7 +13113,7 @@
                 <a:latin typeface="맑은 고딕"/>
                 <a:ea typeface="맑은 고딕"/>
               </a:rPr>
-              <a:t>177</a:t>
+              <a:t>188</a:t>
             </a:r>
           </a:p>
         </p:txBody>
@@ -13240,7 +13241,7 @@
                 <a:latin typeface="맑은 고딕"/>
                 <a:ea typeface="맑은 고딕"/>
               </a:rPr>
-              <a:t>162+</a:t>
+              <a:t>177</a:t>
             </a:r>
           </a:p>
         </p:txBody>
@@ -13426,7 +13427,7 @@
                 <a:latin typeface="맑은 고딕"/>
                 <a:ea typeface="맑은 고딕"/>
               </a:rPr>
-              <a:t>07 · 회고</a:t>
+              <a:t>06 · 운영 준비</a:t>
             </a:r>
           </a:p>
         </p:txBody>
@@ -13440,7 +13441,7 @@
         <p:spPr>
           <a:xfrm>
             <a:off x="822960" y="777240"/>
-            <a:ext cx="10058400" cy="640080"/>
+            <a:ext cx="10515600" cy="640080"/>
           </a:xfrm>
           <a:prstGeom prst="rect">
             <a:avLst/>
@@ -13466,7 +13467,7 @@
                 <a:latin typeface="맑은 고딕"/>
                 <a:ea typeface="맑은 고딕"/>
               </a:rPr>
-              <a:t>잘한 점 &amp; 아쉬운 점</a:t>
+              <a:t>켜 두면 계속 돌아가는 서비스로</a:t>
             </a:r>
           </a:p>
         </p:txBody>
@@ -13479,8 +13480,8 @@
         </p:nvSpPr>
         <p:spPr>
           <a:xfrm>
-            <a:off x="822960" y="1554480"/>
-            <a:ext cx="4846320" cy="365760"/>
+            <a:off x="822960" y="1417320"/>
+            <a:ext cx="10515600" cy="457200"/>
           </a:xfrm>
           <a:prstGeom prst="rect">
             <a:avLst/>
@@ -13499,34 +13500,84 @@
               </a:lnSpc>
             </a:pPr>
             <a:r>
-              <a:rPr sz="1500" b="1" lang="ko-KR">
-                <a:solidFill>
-                  <a:srgbClr val="15803D"/>
-                </a:solidFill>
-                <a:latin typeface="맑은 고딕"/>
-                <a:ea typeface="맑은 고딕"/>
-              </a:rPr>
-              <a:t>잘한 결정</a:t>
-            </a:r>
-          </a:p>
-        </p:txBody>
-      </p:sp>
-      <p:sp>
-        <p:nvSpPr>
-          <p:cNvPr id="5" name="Oval 4"/>
+              <a:rPr sz="1400" b="0" lang="ko-KR">
+                <a:solidFill>
+                  <a:srgbClr val="5F6B7F"/>
+                </a:solidFill>
+                <a:latin typeface="맑은 고딕"/>
+                <a:ea typeface="맑은 고딕"/>
+              </a:rPr>
+              <a:t>내 PC 에서만 돌던 서버를, 꺼지지 않는 클라우드 서버와 매일 백업되는 데이터베이스 위로 옮길 준비를 마쳤습니다.</a:t>
+            </a:r>
+          </a:p>
+        </p:txBody>
+      </p:sp>
+      <p:sp>
+        <p:nvSpPr>
+          <p:cNvPr id="5" name="Rounded Rectangle 4"/>
           <p:cNvSpPr/>
           <p:nvPr/>
         </p:nvSpPr>
         <p:spPr>
           <a:xfrm>
-            <a:off x="822960" y="2084832"/>
-            <a:ext cx="128016" cy="128016"/>
-          </a:xfrm>
-          <a:prstGeom prst="ellipse">
-            <a:avLst/>
+            <a:off x="822960" y="2240280"/>
+            <a:ext cx="3246120" cy="2057400"/>
+          </a:xfrm>
+          <a:prstGeom prst="roundRect">
+            <a:avLst>
+              <a:gd name="adj" fmla="val 8000"/>
+            </a:avLst>
           </a:prstGeom>
           <a:solidFill>
-            <a:srgbClr val="15803D"/>
+            <a:srgbClr val="F6F7FB"/>
+          </a:solidFill>
+          <a:ln w="12700">
+            <a:solidFill>
+              <a:srgbClr val="DFE4EE"/>
+            </a:solidFill>
+          </a:ln>
+          <a:effectLst/>
+        </p:spPr>
+        <p:style>
+          <a:lnRef idx="1">
+            <a:schemeClr val="accent1"/>
+          </a:lnRef>
+          <a:fillRef idx="3">
+            <a:schemeClr val="accent1"/>
+          </a:fillRef>
+          <a:effectRef idx="2">
+            <a:schemeClr val="accent1"/>
+          </a:effectRef>
+          <a:fontRef idx="minor">
+            <a:schemeClr val="lt1"/>
+          </a:fontRef>
+        </p:style>
+        <p:txBody>
+          <a:bodyPr rtlCol="0" anchor="ctr"/>
+          <a:lstStyle/>
+          <a:p>
+            <a:pPr algn="ctr"/>
+          </a:p>
+        </p:txBody>
+      </p:sp>
+      <p:sp>
+        <p:nvSpPr>
+          <p:cNvPr id="6" name="Rounded Rectangle 5"/>
+          <p:cNvSpPr/>
+          <p:nvPr/>
+        </p:nvSpPr>
+        <p:spPr>
+          <a:xfrm>
+            <a:off x="822960" y="2240280"/>
+            <a:ext cx="3246120" cy="109728"/>
+          </a:xfrm>
+          <a:prstGeom prst="roundRect">
+            <a:avLst>
+              <a:gd name="adj" fmla="val 0"/>
+            </a:avLst>
+          </a:prstGeom>
+          <a:solidFill>
+            <a:srgbClr val="4F46E5"/>
           </a:solidFill>
           <a:ln>
             <a:noFill/>
@@ -13557,14 +13608,14 @@
       </p:sp>
       <p:sp>
         <p:nvSpPr>
-          <p:cNvPr id="6" name="TextBox 5"/>
-          <p:cNvSpPr txBox="1"/>
-          <p:nvPr/>
-        </p:nvSpPr>
-        <p:spPr>
-          <a:xfrm>
-            <a:off x="1097280" y="2011680"/>
-            <a:ext cx="4480560" cy="731520"/>
+          <p:cNvPr id="7" name="TextBox 6"/>
+          <p:cNvSpPr txBox="1"/>
+          <p:nvPr/>
+        </p:nvSpPr>
+        <p:spPr>
+          <a:xfrm>
+            <a:off x="1078992" y="2532888"/>
+            <a:ext cx="2788920" cy="411480"/>
           </a:xfrm>
           <a:prstGeom prst="rect">
             <a:avLst/>
@@ -13579,7 +13630,87 @@
           <a:p>
             <a:pPr algn="l">
               <a:lnSpc>
-                <a:spcPct val="140000"/>
+                <a:spcPct val="120000"/>
+              </a:lnSpc>
+            </a:pPr>
+            <a:r>
+              <a:rPr sz="1700" b="1" lang="ko-KR">
+                <a:solidFill>
+                  <a:srgbClr val="101623"/>
+                </a:solidFill>
+                <a:latin typeface="맑은 고딕"/>
+                <a:ea typeface="맑은 고딕"/>
+              </a:rPr>
+              <a:t>화면</a:t>
+            </a:r>
+          </a:p>
+        </p:txBody>
+      </p:sp>
+      <p:sp>
+        <p:nvSpPr>
+          <p:cNvPr id="8" name="TextBox 7"/>
+          <p:cNvSpPr txBox="1"/>
+          <p:nvPr/>
+        </p:nvSpPr>
+        <p:spPr>
+          <a:xfrm>
+            <a:off x="1078992" y="2953512"/>
+            <a:ext cx="2788920" cy="320040"/>
+          </a:xfrm>
+          <a:prstGeom prst="rect">
+            <a:avLst/>
+          </a:prstGeom>
+          <a:noFill/>
+        </p:spPr>
+        <p:txBody>
+          <a:bodyPr wrap="square" anchor="t" lIns="0" rIns="0" tIns="0" bIns="0">
+            <a:spAutoFit/>
+          </a:bodyPr>
+          <a:lstStyle/>
+          <a:p>
+            <a:pPr algn="l">
+              <a:lnSpc>
+                <a:spcPct val="120000"/>
+              </a:lnSpc>
+            </a:pPr>
+            <a:r>
+              <a:rPr sz="1150" b="1" lang="ko-KR">
+                <a:solidFill>
+                  <a:srgbClr val="5F6B7F"/>
+                </a:solidFill>
+                <a:latin typeface="맑은 고딕"/>
+                <a:ea typeface="맑은 고딕"/>
+              </a:rPr>
+              <a:t>Cloudflare</a:t>
+            </a:r>
+          </a:p>
+        </p:txBody>
+      </p:sp>
+      <p:sp>
+        <p:nvSpPr>
+          <p:cNvPr id="9" name="TextBox 8"/>
+          <p:cNvSpPr txBox="1"/>
+          <p:nvPr/>
+        </p:nvSpPr>
+        <p:spPr>
+          <a:xfrm>
+            <a:off x="1078992" y="3383280"/>
+            <a:ext cx="2788920" cy="822960"/>
+          </a:xfrm>
+          <a:prstGeom prst="rect">
+            <a:avLst/>
+          </a:prstGeom>
+          <a:noFill/>
+        </p:spPr>
+        <p:txBody>
+          <a:bodyPr wrap="square" anchor="t" lIns="0" rIns="0" tIns="0" bIns="0">
+            <a:spAutoFit/>
+          </a:bodyPr>
+          <a:lstStyle/>
+          <a:p>
+            <a:pPr algn="l">
+              <a:lnSpc>
+                <a:spcPct val="150000"/>
               </a:lnSpc>
             </a:pPr>
             <a:r>
@@ -13590,27 +13721,129 @@
                 <a:latin typeface="맑은 고딕"/>
                 <a:ea typeface="맑은 고딕"/>
               </a:rPr>
-              <a:t>관리자 콘솔을 별도 앱으로 분리 — 권한 경계를 진지하게 설계하게 됨</a:t>
-            </a:r>
-          </a:p>
-        </p:txBody>
-      </p:sp>
-      <p:sp>
-        <p:nvSpPr>
-          <p:cNvPr id="7" name="Oval 6"/>
+              <a:t>사용자 사이트 · 관리자 콘솔</a:t>
+            </a:r>
+          </a:p>
+          <a:p>
+            <a:pPr algn="l">
+              <a:lnSpc>
+                <a:spcPct val="150000"/>
+              </a:lnSpc>
+            </a:pPr>
+            <a:r>
+              <a:rPr sz="1250" b="0" lang="ko-KR">
+                <a:solidFill>
+                  <a:srgbClr val="2C3646"/>
+                </a:solidFill>
+                <a:latin typeface="맑은 고딕"/>
+                <a:ea typeface="맑은 고딕"/>
+              </a:rPr>
+              <a:t>전 세계 가까운 곳에서 응답</a:t>
+            </a:r>
+          </a:p>
+        </p:txBody>
+      </p:sp>
+      <p:cxnSp>
+        <p:nvCxnSpPr>
+          <p:cNvPr id="10" name="Connector 9"/>
+          <p:cNvCxnSpPr/>
+          <p:nvPr/>
+        </p:nvCxnSpPr>
+        <p:spPr>
+          <a:xfrm>
+            <a:off x="4069080" y="3268980"/>
+            <a:ext cx="384048" cy="0"/>
+          </a:xfrm>
+          <a:prstGeom prst="line">
+            <a:avLst/>
+          </a:prstGeom>
+          <a:ln w="19050">
+            <a:solidFill>
+              <a:srgbClr val="5F6B7F"/>
+            </a:solidFill>
+          </a:ln>
+        </p:spPr>
+        <p:style>
+          <a:lnRef idx="2">
+            <a:schemeClr val="accent1"/>
+          </a:lnRef>
+          <a:fillRef idx="0">
+            <a:schemeClr val="accent1"/>
+          </a:fillRef>
+          <a:effectRef idx="1">
+            <a:schemeClr val="accent1"/>
+          </a:effectRef>
+          <a:fontRef idx="minor">
+            <a:schemeClr val="tx1"/>
+          </a:fontRef>
+        </p:style>
+      </p:cxnSp>
+      <p:sp>
+        <p:nvSpPr>
+          <p:cNvPr id="11" name="Rounded Rectangle 10"/>
           <p:cNvSpPr/>
           <p:nvPr/>
         </p:nvSpPr>
         <p:spPr>
           <a:xfrm>
-            <a:off x="822960" y="2953512"/>
-            <a:ext cx="128016" cy="128016"/>
-          </a:xfrm>
-          <a:prstGeom prst="ellipse">
-            <a:avLst/>
+            <a:off x="4453128" y="2240280"/>
+            <a:ext cx="3246120" cy="2057400"/>
+          </a:xfrm>
+          <a:prstGeom prst="roundRect">
+            <a:avLst>
+              <a:gd name="adj" fmla="val 8000"/>
+            </a:avLst>
           </a:prstGeom>
           <a:solidFill>
-            <a:srgbClr val="15803D"/>
+            <a:srgbClr val="F6F7FB"/>
+          </a:solidFill>
+          <a:ln w="12700">
+            <a:solidFill>
+              <a:srgbClr val="DFE4EE"/>
+            </a:solidFill>
+          </a:ln>
+          <a:effectLst/>
+        </p:spPr>
+        <p:style>
+          <a:lnRef idx="1">
+            <a:schemeClr val="accent1"/>
+          </a:lnRef>
+          <a:fillRef idx="3">
+            <a:schemeClr val="accent1"/>
+          </a:fillRef>
+          <a:effectRef idx="2">
+            <a:schemeClr val="accent1"/>
+          </a:effectRef>
+          <a:fontRef idx="minor">
+            <a:schemeClr val="lt1"/>
+          </a:fontRef>
+        </p:style>
+        <p:txBody>
+          <a:bodyPr rtlCol="0" anchor="ctr"/>
+          <a:lstStyle/>
+          <a:p>
+            <a:pPr algn="ctr"/>
+          </a:p>
+        </p:txBody>
+      </p:sp>
+      <p:sp>
+        <p:nvSpPr>
+          <p:cNvPr id="12" name="Rounded Rectangle 11"/>
+          <p:cNvSpPr/>
+          <p:nvPr/>
+        </p:nvSpPr>
+        <p:spPr>
+          <a:xfrm>
+            <a:off x="4453128" y="2240280"/>
+            <a:ext cx="3246120" cy="109728"/>
+          </a:xfrm>
+          <a:prstGeom prst="roundRect">
+            <a:avLst>
+              <a:gd name="adj" fmla="val 0"/>
+            </a:avLst>
+          </a:prstGeom>
+          <a:solidFill>
+            <a:srgbClr val="14B8A6"/>
           </a:solidFill>
           <a:ln>
             <a:noFill/>
@@ -13641,14 +13874,14 @@
       </p:sp>
       <p:sp>
         <p:nvSpPr>
-          <p:cNvPr id="8" name="TextBox 7"/>
-          <p:cNvSpPr txBox="1"/>
-          <p:nvPr/>
-        </p:nvSpPr>
-        <p:spPr>
-          <a:xfrm>
-            <a:off x="1097280" y="2880360"/>
-            <a:ext cx="4480560" cy="731520"/>
+          <p:cNvPr id="13" name="TextBox 12"/>
+          <p:cNvSpPr txBox="1"/>
+          <p:nvPr/>
+        </p:nvSpPr>
+        <p:spPr>
+          <a:xfrm>
+            <a:off x="4709160" y="2532888"/>
+            <a:ext cx="2788920" cy="411480"/>
           </a:xfrm>
           <a:prstGeom prst="rect">
             <a:avLst/>
@@ -13663,7 +13896,87 @@
           <a:p>
             <a:pPr algn="l">
               <a:lnSpc>
-                <a:spcPct val="140000"/>
+                <a:spcPct val="120000"/>
+              </a:lnSpc>
+            </a:pPr>
+            <a:r>
+              <a:rPr sz="1700" b="1" lang="ko-KR">
+                <a:solidFill>
+                  <a:srgbClr val="101623"/>
+                </a:solidFill>
+                <a:latin typeface="맑은 고딕"/>
+                <a:ea typeface="맑은 고딕"/>
+              </a:rPr>
+              <a:t>서버 · 데이터</a:t>
+            </a:r>
+          </a:p>
+        </p:txBody>
+      </p:sp>
+      <p:sp>
+        <p:nvSpPr>
+          <p:cNvPr id="14" name="TextBox 13"/>
+          <p:cNvSpPr txBox="1"/>
+          <p:nvPr/>
+        </p:nvSpPr>
+        <p:spPr>
+          <a:xfrm>
+            <a:off x="4709160" y="2953512"/>
+            <a:ext cx="2788920" cy="320040"/>
+          </a:xfrm>
+          <a:prstGeom prst="rect">
+            <a:avLst/>
+          </a:prstGeom>
+          <a:noFill/>
+        </p:spPr>
+        <p:txBody>
+          <a:bodyPr wrap="square" anchor="t" lIns="0" rIns="0" tIns="0" bIns="0">
+            <a:spAutoFit/>
+          </a:bodyPr>
+          <a:lstStyle/>
+          <a:p>
+            <a:pPr algn="l">
+              <a:lnSpc>
+                <a:spcPct val="120000"/>
+              </a:lnSpc>
+            </a:pPr>
+            <a:r>
+              <a:rPr sz="1150" b="1" lang="ko-KR">
+                <a:solidFill>
+                  <a:srgbClr val="5F6B7F"/>
+                </a:solidFill>
+                <a:latin typeface="맑은 고딕"/>
+                <a:ea typeface="맑은 고딕"/>
+              </a:rPr>
+              <a:t>Oracle Cloud</a:t>
+            </a:r>
+          </a:p>
+        </p:txBody>
+      </p:sp>
+      <p:sp>
+        <p:nvSpPr>
+          <p:cNvPr id="15" name="TextBox 14"/>
+          <p:cNvSpPr txBox="1"/>
+          <p:nvPr/>
+        </p:nvSpPr>
+        <p:spPr>
+          <a:xfrm>
+            <a:off x="4709160" y="3383280"/>
+            <a:ext cx="2788920" cy="822960"/>
+          </a:xfrm>
+          <a:prstGeom prst="rect">
+            <a:avLst/>
+          </a:prstGeom>
+          <a:noFill/>
+        </p:spPr>
+        <p:txBody>
+          <a:bodyPr wrap="square" anchor="t" lIns="0" rIns="0" tIns="0" bIns="0">
+            <a:spAutoFit/>
+          </a:bodyPr>
+          <a:lstStyle/>
+          <a:p>
+            <a:pPr algn="l">
+              <a:lnSpc>
+                <a:spcPct val="150000"/>
               </a:lnSpc>
             </a:pPr>
             <a:r>
@@ -13674,27 +13987,129 @@
                 <a:latin typeface="맑은 고딕"/>
                 <a:ea typeface="맑은 고딕"/>
               </a:rPr>
-              <a:t>모든 통신을 한 파일(lib/api.ts)로 모아 — 저장 방식이 바뀌어도 고칠 곳이 한 곳</a:t>
-            </a:r>
-          </a:p>
-        </p:txBody>
-      </p:sp>
-      <p:sp>
-        <p:nvSpPr>
-          <p:cNvPr id="9" name="Oval 8"/>
+              <a:t>API 서버 + PostgreSQL</a:t>
+            </a:r>
+          </a:p>
+          <a:p>
+            <a:pPr algn="l">
+              <a:lnSpc>
+                <a:spcPct val="150000"/>
+              </a:lnSpc>
+            </a:pPr>
+            <a:r>
+              <a:rPr sz="1250" b="0" lang="ko-KR">
+                <a:solidFill>
+                  <a:srgbClr val="2C3646"/>
+                </a:solidFill>
+                <a:latin typeface="맑은 고딕"/>
+                <a:ea typeface="맑은 고딕"/>
+              </a:rPr>
+              <a:t>24시간 가동, 자동 HTTPS</a:t>
+            </a:r>
+          </a:p>
+        </p:txBody>
+      </p:sp>
+      <p:cxnSp>
+        <p:nvCxnSpPr>
+          <p:cNvPr id="16" name="Connector 15"/>
+          <p:cNvCxnSpPr/>
+          <p:nvPr/>
+        </p:nvCxnSpPr>
+        <p:spPr>
+          <a:xfrm>
+            <a:off x="7699248" y="3268980"/>
+            <a:ext cx="384048" cy="0"/>
+          </a:xfrm>
+          <a:prstGeom prst="line">
+            <a:avLst/>
+          </a:prstGeom>
+          <a:ln w="19050">
+            <a:solidFill>
+              <a:srgbClr val="5F6B7F"/>
+            </a:solidFill>
+          </a:ln>
+        </p:spPr>
+        <p:style>
+          <a:lnRef idx="2">
+            <a:schemeClr val="accent1"/>
+          </a:lnRef>
+          <a:fillRef idx="0">
+            <a:schemeClr val="accent1"/>
+          </a:fillRef>
+          <a:effectRef idx="1">
+            <a:schemeClr val="accent1"/>
+          </a:effectRef>
+          <a:fontRef idx="minor">
+            <a:schemeClr val="tx1"/>
+          </a:fontRef>
+        </p:style>
+      </p:cxnSp>
+      <p:sp>
+        <p:nvSpPr>
+          <p:cNvPr id="17" name="Rounded Rectangle 16"/>
           <p:cNvSpPr/>
           <p:nvPr/>
         </p:nvSpPr>
         <p:spPr>
           <a:xfrm>
-            <a:off x="822960" y="3822192"/>
-            <a:ext cx="128016" cy="128016"/>
-          </a:xfrm>
-          <a:prstGeom prst="ellipse">
-            <a:avLst/>
+            <a:off x="8083296" y="2240280"/>
+            <a:ext cx="3246120" cy="2057400"/>
+          </a:xfrm>
+          <a:prstGeom prst="roundRect">
+            <a:avLst>
+              <a:gd name="adj" fmla="val 8000"/>
+            </a:avLst>
           </a:prstGeom>
           <a:solidFill>
-            <a:srgbClr val="15803D"/>
+            <a:srgbClr val="F6F7FB"/>
+          </a:solidFill>
+          <a:ln w="12700">
+            <a:solidFill>
+              <a:srgbClr val="DFE4EE"/>
+            </a:solidFill>
+          </a:ln>
+          <a:effectLst/>
+        </p:spPr>
+        <p:style>
+          <a:lnRef idx="1">
+            <a:schemeClr val="accent1"/>
+          </a:lnRef>
+          <a:fillRef idx="3">
+            <a:schemeClr val="accent1"/>
+          </a:fillRef>
+          <a:effectRef idx="2">
+            <a:schemeClr val="accent1"/>
+          </a:effectRef>
+          <a:fontRef idx="minor">
+            <a:schemeClr val="lt1"/>
+          </a:fontRef>
+        </p:style>
+        <p:txBody>
+          <a:bodyPr rtlCol="0" anchor="ctr"/>
+          <a:lstStyle/>
+          <a:p>
+            <a:pPr algn="ctr"/>
+          </a:p>
+        </p:txBody>
+      </p:sp>
+      <p:sp>
+        <p:nvSpPr>
+          <p:cNvPr id="18" name="Rounded Rectangle 17"/>
+          <p:cNvSpPr/>
+          <p:nvPr/>
+        </p:nvSpPr>
+        <p:spPr>
+          <a:xfrm>
+            <a:off x="8083296" y="2240280"/>
+            <a:ext cx="3246120" cy="109728"/>
+          </a:xfrm>
+          <a:prstGeom prst="roundRect">
+            <a:avLst>
+              <a:gd name="adj" fmla="val 0"/>
+            </a:avLst>
+          </a:prstGeom>
+          <a:solidFill>
+            <a:srgbClr val="B45309"/>
           </a:solidFill>
           <a:ln>
             <a:noFill/>
@@ -13725,14 +14140,14 @@
       </p:sp>
       <p:sp>
         <p:nvSpPr>
-          <p:cNvPr id="10" name="TextBox 9"/>
-          <p:cNvSpPr txBox="1"/>
-          <p:nvPr/>
-        </p:nvSpPr>
-        <p:spPr>
-          <a:xfrm>
-            <a:off x="1097280" y="3749040"/>
-            <a:ext cx="4480560" cy="731520"/>
+          <p:cNvPr id="19" name="TextBox 18"/>
+          <p:cNvSpPr txBox="1"/>
+          <p:nvPr/>
+        </p:nvSpPr>
+        <p:spPr>
+          <a:xfrm>
+            <a:off x="8339328" y="2532888"/>
+            <a:ext cx="2788920" cy="411480"/>
           </a:xfrm>
           <a:prstGeom prst="rect">
             <a:avLst/>
@@ -13747,7 +14162,87 @@
           <a:p>
             <a:pPr algn="l">
               <a:lnSpc>
-                <a:spcPct val="140000"/>
+                <a:spcPct val="120000"/>
+              </a:lnSpc>
+            </a:pPr>
+            <a:r>
+              <a:rPr sz="1700" b="1" lang="ko-KR">
+                <a:solidFill>
+                  <a:srgbClr val="101623"/>
+                </a:solidFill>
+                <a:latin typeface="맑은 고딕"/>
+                <a:ea typeface="맑은 고딕"/>
+              </a:rPr>
+              <a:t>백업</a:t>
+            </a:r>
+          </a:p>
+        </p:txBody>
+      </p:sp>
+      <p:sp>
+        <p:nvSpPr>
+          <p:cNvPr id="20" name="TextBox 19"/>
+          <p:cNvSpPr txBox="1"/>
+          <p:nvPr/>
+        </p:nvSpPr>
+        <p:spPr>
+          <a:xfrm>
+            <a:off x="8339328" y="2953512"/>
+            <a:ext cx="2788920" cy="320040"/>
+          </a:xfrm>
+          <a:prstGeom prst="rect">
+            <a:avLst/>
+          </a:prstGeom>
+          <a:noFill/>
+        </p:spPr>
+        <p:txBody>
+          <a:bodyPr wrap="square" anchor="t" lIns="0" rIns="0" tIns="0" bIns="0">
+            <a:spAutoFit/>
+          </a:bodyPr>
+          <a:lstStyle/>
+          <a:p>
+            <a:pPr algn="l">
+              <a:lnSpc>
+                <a:spcPct val="120000"/>
+              </a:lnSpc>
+            </a:pPr>
+            <a:r>
+              <a:rPr sz="1150" b="1" lang="ko-KR">
+                <a:solidFill>
+                  <a:srgbClr val="5F6B7F"/>
+                </a:solidFill>
+                <a:latin typeface="맑은 고딕"/>
+                <a:ea typeface="맑은 고딕"/>
+              </a:rPr>
+              <a:t>내 PC (D 드라이브)</a:t>
+            </a:r>
+          </a:p>
+        </p:txBody>
+      </p:sp>
+      <p:sp>
+        <p:nvSpPr>
+          <p:cNvPr id="21" name="TextBox 20"/>
+          <p:cNvSpPr txBox="1"/>
+          <p:nvPr/>
+        </p:nvSpPr>
+        <p:spPr>
+          <a:xfrm>
+            <a:off x="8339328" y="3383280"/>
+            <a:ext cx="2788920" cy="822960"/>
+          </a:xfrm>
+          <a:prstGeom prst="rect">
+            <a:avLst/>
+          </a:prstGeom>
+          <a:noFill/>
+        </p:spPr>
+        <p:txBody>
+          <a:bodyPr wrap="square" anchor="t" lIns="0" rIns="0" tIns="0" bIns="0">
+            <a:spAutoFit/>
+          </a:bodyPr>
+          <a:lstStyle/>
+          <a:p>
+            <a:pPr algn="l">
+              <a:lnSpc>
+                <a:spcPct val="150000"/>
               </a:lnSpc>
             </a:pPr>
             <a:r>
@@ -13758,21 +14253,38 @@
                 <a:latin typeface="맑은 고딕"/>
                 <a:ea typeface="맑은 고딕"/>
               </a:rPr>
-              <a:t>한계를 문서에 그대로 적어 둠 — 모르는 것과 알고 미룬 것은 다르다</a:t>
-            </a:r>
-          </a:p>
-        </p:txBody>
-      </p:sp>
-      <p:sp>
-        <p:nvSpPr>
-          <p:cNvPr id="11" name="TextBox 10"/>
-          <p:cNvSpPr txBox="1"/>
-          <p:nvPr/>
-        </p:nvSpPr>
-        <p:spPr>
-          <a:xfrm>
-            <a:off x="6309360" y="1554480"/>
-            <a:ext cx="4846320" cy="365760"/>
+              <a:t>매일 새벽 데이터 사본을</a:t>
+            </a:r>
+          </a:p>
+          <a:p>
+            <a:pPr algn="l">
+              <a:lnSpc>
+                <a:spcPct val="150000"/>
+              </a:lnSpc>
+            </a:pPr>
+            <a:r>
+              <a:rPr sz="1250" b="0" lang="ko-KR">
+                <a:solidFill>
+                  <a:srgbClr val="2C3646"/>
+                </a:solidFill>
+                <a:latin typeface="맑은 고딕"/>
+                <a:ea typeface="맑은 고딕"/>
+              </a:rPr>
+              <a:t>내려받아 보관 · 복원 확인</a:t>
+            </a:r>
+          </a:p>
+        </p:txBody>
+      </p:sp>
+      <p:sp>
+        <p:nvSpPr>
+          <p:cNvPr id="22" name="TextBox 21"/>
+          <p:cNvSpPr txBox="1"/>
+          <p:nvPr/>
+        </p:nvSpPr>
+        <p:spPr>
+          <a:xfrm>
+            <a:off x="822960" y="4572000"/>
+            <a:ext cx="822960" cy="548640"/>
           </a:xfrm>
           <a:prstGeom prst="rect">
             <a:avLst/>
@@ -13791,72 +14303,28 @@
               </a:lnSpc>
             </a:pPr>
             <a:r>
-              <a:rPr sz="1500" b="1" lang="ko-KR">
-                <a:solidFill>
-                  <a:srgbClr val="B42318"/>
-                </a:solidFill>
-                <a:latin typeface="맑은 고딕"/>
-                <a:ea typeface="맑은 고딕"/>
-              </a:rPr>
-              <a:t>아쉬운 점</a:t>
-            </a:r>
-          </a:p>
-        </p:txBody>
-      </p:sp>
-      <p:sp>
-        <p:nvSpPr>
-          <p:cNvPr id="12" name="Oval 11"/>
-          <p:cNvSpPr/>
-          <p:nvPr/>
-        </p:nvSpPr>
-        <p:spPr>
-          <a:xfrm>
-            <a:off x="6309360" y="2084832"/>
-            <a:ext cx="128016" cy="128016"/>
-          </a:xfrm>
-          <a:prstGeom prst="ellipse">
-            <a:avLst/>
-          </a:prstGeom>
-          <a:solidFill>
-            <a:srgbClr val="B42318"/>
-          </a:solidFill>
-          <a:ln>
-            <a:noFill/>
-          </a:ln>
-          <a:effectLst/>
-        </p:spPr>
-        <p:style>
-          <a:lnRef idx="1">
-            <a:schemeClr val="accent1"/>
-          </a:lnRef>
-          <a:fillRef idx="3">
-            <a:schemeClr val="accent1"/>
-          </a:fillRef>
-          <a:effectRef idx="2">
-            <a:schemeClr val="accent1"/>
-          </a:effectRef>
-          <a:fontRef idx="minor">
-            <a:schemeClr val="lt1"/>
-          </a:fontRef>
-        </p:style>
-        <p:txBody>
-          <a:bodyPr rtlCol="0" anchor="ctr"/>
-          <a:lstStyle/>
-          <a:p>
-            <a:pPr algn="ctr"/>
-          </a:p>
-        </p:txBody>
-      </p:sp>
-      <p:sp>
-        <p:nvSpPr>
-          <p:cNvPr id="13" name="TextBox 12"/>
-          <p:cNvSpPr txBox="1"/>
-          <p:nvPr/>
-        </p:nvSpPr>
-        <p:spPr>
-          <a:xfrm>
-            <a:off x="6583680" y="2011680"/>
-            <a:ext cx="4572000" cy="731520"/>
+              <a:rPr sz="2400" b="1" lang="ko-KR">
+                <a:solidFill>
+                  <a:srgbClr val="4F46E5"/>
+                </a:solidFill>
+                <a:latin typeface="맑은 고딕"/>
+                <a:ea typeface="맑은 고딕"/>
+              </a:rPr>
+              <a:t>180</a:t>
+            </a:r>
+          </a:p>
+        </p:txBody>
+      </p:sp>
+      <p:sp>
+        <p:nvSpPr>
+          <p:cNvPr id="23" name="TextBox 22"/>
+          <p:cNvSpPr txBox="1"/>
+          <p:nvPr/>
+        </p:nvSpPr>
+        <p:spPr>
+          <a:xfrm>
+            <a:off x="1600200" y="4645152"/>
+            <a:ext cx="2743200" cy="685800"/>
           </a:xfrm>
           <a:prstGeom prst="rect">
             <a:avLst/>
@@ -13871,76 +14339,32 @@
           <a:p>
             <a:pPr algn="l">
               <a:lnSpc>
-                <a:spcPct val="140000"/>
-              </a:lnSpc>
-            </a:pPr>
-            <a:r>
-              <a:rPr sz="1250" b="0" lang="ko-KR">
+                <a:spcPct val="135000"/>
+              </a:lnSpc>
+            </a:pPr>
+            <a:r>
+              <a:rPr sz="1200" b="0" lang="ko-KR">
                 <a:solidFill>
                   <a:srgbClr val="2C3646"/>
                 </a:solidFill>
                 <a:latin typeface="맑은 고딕"/>
                 <a:ea typeface="맑은 고딕"/>
               </a:rPr>
-              <a:t>CI를 마지막까지 미룸 — 테스트 177건을 만들고도 자동 실행은 수동</a:t>
-            </a:r>
-          </a:p>
-        </p:txBody>
-      </p:sp>
-      <p:sp>
-        <p:nvSpPr>
-          <p:cNvPr id="14" name="Oval 13"/>
-          <p:cNvSpPr/>
-          <p:nvPr/>
-        </p:nvSpPr>
-        <p:spPr>
-          <a:xfrm>
-            <a:off x="6309360" y="2953512"/>
-            <a:ext cx="128016" cy="128016"/>
-          </a:xfrm>
-          <a:prstGeom prst="ellipse">
-            <a:avLst/>
-          </a:prstGeom>
-          <a:solidFill>
-            <a:srgbClr val="B42318"/>
-          </a:solidFill>
-          <a:ln>
-            <a:noFill/>
-          </a:ln>
-          <a:effectLst/>
-        </p:spPr>
-        <p:style>
-          <a:lnRef idx="1">
-            <a:schemeClr val="accent1"/>
-          </a:lnRef>
-          <a:fillRef idx="3">
-            <a:schemeClr val="accent1"/>
-          </a:fillRef>
-          <a:effectRef idx="2">
-            <a:schemeClr val="accent1"/>
-          </a:effectRef>
-          <a:fontRef idx="minor">
-            <a:schemeClr val="lt1"/>
-          </a:fontRef>
-        </p:style>
-        <p:txBody>
-          <a:bodyPr rtlCol="0" anchor="ctr"/>
-          <a:lstStyle/>
-          <a:p>
-            <a:pPr algn="ctr"/>
-          </a:p>
-        </p:txBody>
-      </p:sp>
-      <p:sp>
-        <p:nvSpPr>
-          <p:cNvPr id="15" name="TextBox 14"/>
-          <p:cNvSpPr txBox="1"/>
-          <p:nvPr/>
-        </p:nvSpPr>
-        <p:spPr>
-          <a:xfrm>
-            <a:off x="6583680" y="2880360"/>
-            <a:ext cx="4572000" cy="731520"/>
+              <a:t>개의 자동 검사가 코드를 올릴 때마다 실행</a:t>
+            </a:r>
+          </a:p>
+        </p:txBody>
+      </p:sp>
+      <p:sp>
+        <p:nvSpPr>
+          <p:cNvPr id="24" name="TextBox 23"/>
+          <p:cNvSpPr txBox="1"/>
+          <p:nvPr/>
+        </p:nvSpPr>
+        <p:spPr>
+          <a:xfrm>
+            <a:off x="4434840" y="4572000"/>
+            <a:ext cx="822960" cy="548640"/>
           </a:xfrm>
           <a:prstGeom prst="rect">
             <a:avLst/>
@@ -13955,76 +14379,72 @@
           <a:p>
             <a:pPr algn="l">
               <a:lnSpc>
-                <a:spcPct val="140000"/>
-              </a:lnSpc>
-            </a:pPr>
-            <a:r>
-              <a:rPr sz="1250" b="0" lang="ko-KR">
+                <a:spcPct val="120000"/>
+              </a:lnSpc>
+            </a:pPr>
+            <a:r>
+              <a:rPr sz="2400" b="1" lang="ko-KR">
+                <a:solidFill>
+                  <a:srgbClr val="4F46E5"/>
+                </a:solidFill>
+                <a:latin typeface="맑은 고딕"/>
+                <a:ea typeface="맑은 고딕"/>
+              </a:rPr>
+              <a:t>151</a:t>
+            </a:r>
+          </a:p>
+        </p:txBody>
+      </p:sp>
+      <p:sp>
+        <p:nvSpPr>
+          <p:cNvPr id="25" name="TextBox 24"/>
+          <p:cNvSpPr txBox="1"/>
+          <p:nvPr/>
+        </p:nvSpPr>
+        <p:spPr>
+          <a:xfrm>
+            <a:off x="5212080" y="4645152"/>
+            <a:ext cx="2743200" cy="685800"/>
+          </a:xfrm>
+          <a:prstGeom prst="rect">
+            <a:avLst/>
+          </a:prstGeom>
+          <a:noFill/>
+        </p:spPr>
+        <p:txBody>
+          <a:bodyPr wrap="square" anchor="t" lIns="0" rIns="0" tIns="0" bIns="0">
+            <a:spAutoFit/>
+          </a:bodyPr>
+          <a:lstStyle/>
+          <a:p>
+            <a:pPr algn="l">
+              <a:lnSpc>
+                <a:spcPct val="135000"/>
+              </a:lnSpc>
+            </a:pPr>
+            <a:r>
+              <a:rPr sz="1200" b="0" lang="ko-KR">
                 <a:solidFill>
                   <a:srgbClr val="2C3646"/>
                 </a:solidFill>
                 <a:latin typeface="맑은 고딕"/>
                 <a:ea typeface="맑은 고딕"/>
               </a:rPr>
-              <a:t>일부 코드 파일이 비대해짐 — 초반에 나눴다면 지금 분할 비용이 없었을 것</a:t>
-            </a:r>
-          </a:p>
-        </p:txBody>
-      </p:sp>
-      <p:sp>
-        <p:nvSpPr>
-          <p:cNvPr id="16" name="Oval 15"/>
-          <p:cNvSpPr/>
-          <p:nvPr/>
-        </p:nvSpPr>
-        <p:spPr>
-          <a:xfrm>
-            <a:off x="6309360" y="3822192"/>
-            <a:ext cx="128016" cy="128016"/>
-          </a:xfrm>
-          <a:prstGeom prst="ellipse">
-            <a:avLst/>
-          </a:prstGeom>
-          <a:solidFill>
-            <a:srgbClr val="B42318"/>
-          </a:solidFill>
-          <a:ln>
-            <a:noFill/>
-          </a:ln>
-          <a:effectLst/>
-        </p:spPr>
-        <p:style>
-          <a:lnRef idx="1">
-            <a:schemeClr val="accent1"/>
-          </a:lnRef>
-          <a:fillRef idx="3">
-            <a:schemeClr val="accent1"/>
-          </a:fillRef>
-          <a:effectRef idx="2">
-            <a:schemeClr val="accent1"/>
-          </a:effectRef>
-          <a:fontRef idx="minor">
-            <a:schemeClr val="lt1"/>
-          </a:fontRef>
-        </p:style>
-        <p:txBody>
-          <a:bodyPr rtlCol="0" anchor="ctr"/>
-          <a:lstStyle/>
-          <a:p>
-            <a:pPr algn="ctr"/>
-          </a:p>
-        </p:txBody>
-      </p:sp>
-      <p:sp>
-        <p:nvSpPr>
-          <p:cNvPr id="17" name="TextBox 16"/>
-          <p:cNvSpPr txBox="1"/>
-          <p:nvPr/>
-        </p:nvSpPr>
-        <p:spPr>
-          <a:xfrm>
-            <a:off x="6583680" y="3749040"/>
-            <a:ext cx="4572000" cy="731520"/>
+              <a:t>건의 기존 데이터를 새 데이터베이스로 빠짐없이 이전</a:t>
+            </a:r>
+          </a:p>
+        </p:txBody>
+      </p:sp>
+      <p:sp>
+        <p:nvSpPr>
+          <p:cNvPr id="26" name="TextBox 25"/>
+          <p:cNvSpPr txBox="1"/>
+          <p:nvPr/>
+        </p:nvSpPr>
+        <p:spPr>
+          <a:xfrm>
+            <a:off x="8046720" y="4572000"/>
+            <a:ext cx="822960" cy="548640"/>
           </a:xfrm>
           <a:prstGeom prst="rect">
             <a:avLst/>
@@ -14039,25 +14459,115 @@
           <a:p>
             <a:pPr algn="l">
               <a:lnSpc>
-                <a:spcPct val="140000"/>
-              </a:lnSpc>
-            </a:pPr>
-            <a:r>
-              <a:rPr sz="1250" b="0" lang="ko-KR">
+                <a:spcPct val="120000"/>
+              </a:lnSpc>
+            </a:pPr>
+            <a:r>
+              <a:rPr sz="2400" b="1" lang="ko-KR">
+                <a:solidFill>
+                  <a:srgbClr val="4F46E5"/>
+                </a:solidFill>
+                <a:latin typeface="맑은 고딕"/>
+                <a:ea typeface="맑은 고딕"/>
+              </a:rPr>
+              <a:t>1번</a:t>
+            </a:r>
+          </a:p>
+        </p:txBody>
+      </p:sp>
+      <p:sp>
+        <p:nvSpPr>
+          <p:cNvPr id="27" name="TextBox 26"/>
+          <p:cNvSpPr txBox="1"/>
+          <p:nvPr/>
+        </p:nvSpPr>
+        <p:spPr>
+          <a:xfrm>
+            <a:off x="8823960" y="4645152"/>
+            <a:ext cx="2743200" cy="685800"/>
+          </a:xfrm>
+          <a:prstGeom prst="rect">
+            <a:avLst/>
+          </a:prstGeom>
+          <a:noFill/>
+        </p:spPr>
+        <p:txBody>
+          <a:bodyPr wrap="square" anchor="t" lIns="0" rIns="0" tIns="0" bIns="0">
+            <a:spAutoFit/>
+          </a:bodyPr>
+          <a:lstStyle/>
+          <a:p>
+            <a:pPr algn="l">
+              <a:lnSpc>
+                <a:spcPct val="135000"/>
+              </a:lnSpc>
+            </a:pPr>
+            <a:r>
+              <a:rPr sz="1200" b="0" lang="ko-KR">
                 <a:solidFill>
                   <a:srgbClr val="2C3646"/>
                 </a:solidFill>
                 <a:latin typeface="맑은 고딕"/>
                 <a:ea typeface="맑은 고딕"/>
               </a:rPr>
-              <a:t>성능·접근성을 측정한 적이 없음 — 기능이 안정된 지금이 잴 시점</a:t>
-            </a:r>
-          </a:p>
-        </p:txBody>
-      </p:sp>
-      <p:sp>
-        <p:nvSpPr>
-          <p:cNvPr id="18" name="TextBox 17"/>
+              <a:t>명령으로 백업 → 업데이트 → 상태 확인까지</a:t>
+            </a:r>
+          </a:p>
+        </p:txBody>
+      </p:sp>
+      <p:sp>
+        <p:nvSpPr>
+          <p:cNvPr id="28" name="TextBox 27"/>
+          <p:cNvSpPr txBox="1"/>
+          <p:nvPr/>
+        </p:nvSpPr>
+        <p:spPr>
+          <a:xfrm>
+            <a:off x="822960" y="5532120"/>
+            <a:ext cx="10515600" cy="548640"/>
+          </a:xfrm>
+          <a:prstGeom prst="rect">
+            <a:avLst/>
+          </a:prstGeom>
+          <a:noFill/>
+        </p:spPr>
+        <p:txBody>
+          <a:bodyPr wrap="square" anchor="t" lIns="0" rIns="0" tIns="0" bIns="0">
+            <a:spAutoFit/>
+          </a:bodyPr>
+          <a:lstStyle/>
+          <a:p>
+            <a:pPr algn="l">
+              <a:lnSpc>
+                <a:spcPct val="130000"/>
+              </a:lnSpc>
+            </a:pPr>
+            <a:r>
+              <a:rPr sz="1350" b="1" lang="ko-KR">
+                <a:solidFill>
+                  <a:srgbClr val="4F46E5"/>
+                </a:solidFill>
+                <a:latin typeface="맑은 고딕"/>
+                <a:ea typeface="맑은 고딕"/>
+              </a:rPr>
+              <a:t>남은 일  </a:t>
+            </a:r>
+            <a:r>
+              <a:rPr sz="1350" b="0" lang="ko-KR">
+                <a:solidFill>
+                  <a:srgbClr val="2C3646"/>
+                </a:solidFill>
+                <a:latin typeface="맑은 고딕"/>
+                <a:ea typeface="맑은 고딕"/>
+              </a:rPr>
+              <a:t>클라우드 서버를 만들고 도메인을 연결하면, 링크 하나로 모든 기능이 동작하는 라이브 서비스가 됩니다.</a:t>
+            </a:r>
+          </a:p>
+        </p:txBody>
+      </p:sp>
+      <p:sp>
+        <p:nvSpPr>
+          <p:cNvPr id="29" name="TextBox 28"/>
           <p:cNvSpPr txBox="1"/>
           <p:nvPr/>
         </p:nvSpPr>
@@ -14097,7 +14607,7 @@
       </p:sp>
       <p:sp>
         <p:nvSpPr>
-          <p:cNvPr id="19" name="TextBox 18"/>
+          <p:cNvPr id="30" name="TextBox 29"/>
           <p:cNvSpPr txBox="1"/>
           <p:nvPr/>
         </p:nvSpPr>
@@ -14196,7 +14706,7 @@
                 <a:latin typeface="맑은 고딕"/>
                 <a:ea typeface="맑은 고딕"/>
               </a:rPr>
-              <a:t>07 · 다음 계획</a:t>
+              <a:t>07 · 회고</a:t>
             </a:r>
           </a:p>
         </p:txBody>
@@ -14236,29 +14746,67 @@
                 <a:latin typeface="맑은 고딕"/>
                 <a:ea typeface="맑은 고딕"/>
               </a:rPr>
-              <a:t>앞으로의 방향</a:t>
-            </a:r>
-          </a:p>
-        </p:txBody>
-      </p:sp>
-      <p:sp>
-        <p:nvSpPr>
-          <p:cNvPr id="4" name="Rounded Rectangle 3"/>
+              <a:t>잘한 점 &amp; 아쉬운 점</a:t>
+            </a:r>
+          </a:p>
+        </p:txBody>
+      </p:sp>
+      <p:sp>
+        <p:nvSpPr>
+          <p:cNvPr id="4" name="TextBox 3"/>
+          <p:cNvSpPr txBox="1"/>
+          <p:nvPr/>
+        </p:nvSpPr>
+        <p:spPr>
+          <a:xfrm>
+            <a:off x="822960" y="1554480"/>
+            <a:ext cx="4846320" cy="365760"/>
+          </a:xfrm>
+          <a:prstGeom prst="rect">
+            <a:avLst/>
+          </a:prstGeom>
+          <a:noFill/>
+        </p:spPr>
+        <p:txBody>
+          <a:bodyPr wrap="square" anchor="t" lIns="0" rIns="0" tIns="0" bIns="0">
+            <a:spAutoFit/>
+          </a:bodyPr>
+          <a:lstStyle/>
+          <a:p>
+            <a:pPr algn="l">
+              <a:lnSpc>
+                <a:spcPct val="120000"/>
+              </a:lnSpc>
+            </a:pPr>
+            <a:r>
+              <a:rPr sz="1500" b="1" lang="ko-KR">
+                <a:solidFill>
+                  <a:srgbClr val="15803D"/>
+                </a:solidFill>
+                <a:latin typeface="맑은 고딕"/>
+                <a:ea typeface="맑은 고딕"/>
+              </a:rPr>
+              <a:t>잘한 결정</a:t>
+            </a:r>
+          </a:p>
+        </p:txBody>
+      </p:sp>
+      <p:sp>
+        <p:nvSpPr>
+          <p:cNvPr id="5" name="Oval 4"/>
           <p:cNvSpPr/>
           <p:nvPr/>
         </p:nvSpPr>
         <p:spPr>
           <a:xfrm>
-            <a:off x="822960" y="1691640"/>
-            <a:ext cx="457200" cy="457200"/>
-          </a:xfrm>
-          <a:prstGeom prst="roundRect">
-            <a:avLst>
-              <a:gd name="adj" fmla="val 50000"/>
-            </a:avLst>
+            <a:off x="822960" y="2084832"/>
+            <a:ext cx="128016" cy="128016"/>
+          </a:xfrm>
+          <a:prstGeom prst="ellipse">
+            <a:avLst/>
           </a:prstGeom>
           <a:solidFill>
-            <a:srgbClr val="4F46E5"/>
+            <a:srgbClr val="15803D"/>
           </a:solidFill>
           <a:ln>
             <a:noFill/>
@@ -14280,60 +14828,10 @@
           </a:fontRef>
         </p:style>
         <p:txBody>
-          <a:bodyPr rtlCol="0" anchor="ctr" wrap="none" lIns="25400" rIns="25400"/>
+          <a:bodyPr rtlCol="0" anchor="ctr"/>
           <a:lstStyle/>
           <a:p>
             <a:pPr algn="ctr"/>
-            <a:r>
-              <a:rPr sz="1400" b="1" lang="ko-KR">
-                <a:solidFill>
-                  <a:srgbClr val="FFFFFF"/>
-                </a:solidFill>
-                <a:latin typeface="맑은 고딕"/>
-                <a:ea typeface="맑은 고딕"/>
-              </a:rPr>
-              <a:t>1</a:t>
-            </a:r>
-          </a:p>
-        </p:txBody>
-      </p:sp>
-      <p:sp>
-        <p:nvSpPr>
-          <p:cNvPr id="5" name="TextBox 4"/>
-          <p:cNvSpPr txBox="1"/>
-          <p:nvPr/>
-        </p:nvSpPr>
-        <p:spPr>
-          <a:xfrm>
-            <a:off x="1508760" y="1673352"/>
-            <a:ext cx="2834640" cy="502920"/>
-          </a:xfrm>
-          <a:prstGeom prst="rect">
-            <a:avLst/>
-          </a:prstGeom>
-          <a:noFill/>
-        </p:spPr>
-        <p:txBody>
-          <a:bodyPr wrap="square" anchor="ctr" lIns="0" rIns="0" tIns="0" bIns="0">
-            <a:spAutoFit/>
-          </a:bodyPr>
-          <a:lstStyle/>
-          <a:p>
-            <a:pPr algn="l">
-              <a:lnSpc>
-                <a:spcPct val="120000"/>
-              </a:lnSpc>
-            </a:pPr>
-            <a:r>
-              <a:rPr sz="1500" b="1" lang="ko-KR">
-                <a:solidFill>
-                  <a:srgbClr val="101623"/>
-                </a:solidFill>
-                <a:latin typeface="맑은 고딕"/>
-                <a:ea typeface="맑은 고딕"/>
-              </a:rPr>
-              <a:t>백엔드 공개 배포</a:t>
-            </a:r>
           </a:p>
         </p:txBody>
       </p:sp>
@@ -14345,56 +14843,54 @@
         </p:nvSpPr>
         <p:spPr>
           <a:xfrm>
-            <a:off x="4572000" y="1691640"/>
-            <a:ext cx="6675120" cy="502920"/>
-          </a:xfrm>
-          <a:prstGeom prst="rect">
-            <a:avLst/>
-          </a:prstGeom>
-          <a:noFill/>
-        </p:spPr>
-        <p:txBody>
-          <a:bodyPr wrap="square" anchor="ctr" lIns="0" rIns="0" tIns="0" bIns="0">
-            <a:spAutoFit/>
-          </a:bodyPr>
-          <a:lstStyle/>
-          <a:p>
-            <a:pPr algn="l">
-              <a:lnSpc>
-                <a:spcPct val="120000"/>
-              </a:lnSpc>
-            </a:pPr>
-            <a:r>
-              <a:rPr sz="1300" b="0" lang="ko-KR">
-                <a:solidFill>
-                  <a:srgbClr val="5F6B7F"/>
-                </a:solidFill>
-                <a:latin typeface="맑은 고딕"/>
-                <a:ea typeface="맑은 고딕"/>
-              </a:rPr>
-              <a:t>링크 하나로 전체 기능이 동작하는 라이브 데모 완성</a:t>
-            </a:r>
-          </a:p>
-        </p:txBody>
-      </p:sp>
-      <p:sp>
-        <p:nvSpPr>
-          <p:cNvPr id="7" name="Rounded Rectangle 6"/>
+            <a:off x="1097280" y="2011680"/>
+            <a:ext cx="4480560" cy="731520"/>
+          </a:xfrm>
+          <a:prstGeom prst="rect">
+            <a:avLst/>
+          </a:prstGeom>
+          <a:noFill/>
+        </p:spPr>
+        <p:txBody>
+          <a:bodyPr wrap="square" anchor="t" lIns="0" rIns="0" tIns="0" bIns="0">
+            <a:spAutoFit/>
+          </a:bodyPr>
+          <a:lstStyle/>
+          <a:p>
+            <a:pPr algn="l">
+              <a:lnSpc>
+                <a:spcPct val="140000"/>
+              </a:lnSpc>
+            </a:pPr>
+            <a:r>
+              <a:rPr sz="1250" b="0" lang="ko-KR">
+                <a:solidFill>
+                  <a:srgbClr val="2C3646"/>
+                </a:solidFill>
+                <a:latin typeface="맑은 고딕"/>
+                <a:ea typeface="맑은 고딕"/>
+              </a:rPr>
+              <a:t>관리자 콘솔을 별도 앱으로 분리 — 권한 경계를 진지하게 설계하게 됨</a:t>
+            </a:r>
+          </a:p>
+        </p:txBody>
+      </p:sp>
+      <p:sp>
+        <p:nvSpPr>
+          <p:cNvPr id="7" name="Oval 6"/>
           <p:cNvSpPr/>
           <p:nvPr/>
         </p:nvSpPr>
         <p:spPr>
           <a:xfrm>
-            <a:off x="822960" y="2468880"/>
-            <a:ext cx="457200" cy="457200"/>
-          </a:xfrm>
-          <a:prstGeom prst="roundRect">
-            <a:avLst>
-              <a:gd name="adj" fmla="val 50000"/>
-            </a:avLst>
+            <a:off x="822960" y="2953512"/>
+            <a:ext cx="128016" cy="128016"/>
+          </a:xfrm>
+          <a:prstGeom prst="ellipse">
+            <a:avLst/>
           </a:prstGeom>
           <a:solidFill>
-            <a:srgbClr val="4F46E5"/>
+            <a:srgbClr val="15803D"/>
           </a:solidFill>
           <a:ln>
             <a:noFill/>
@@ -14416,20 +14912,10 @@
           </a:fontRef>
         </p:style>
         <p:txBody>
-          <a:bodyPr rtlCol="0" anchor="ctr" wrap="none" lIns="25400" rIns="25400"/>
+          <a:bodyPr rtlCol="0" anchor="ctr"/>
           <a:lstStyle/>
           <a:p>
             <a:pPr algn="ctr"/>
-            <a:r>
-              <a:rPr sz="1400" b="1" lang="ko-KR">
-                <a:solidFill>
-                  <a:srgbClr val="FFFFFF"/>
-                </a:solidFill>
-                <a:latin typeface="맑은 고딕"/>
-                <a:ea typeface="맑은 고딕"/>
-              </a:rPr>
-              <a:t>2</a:t>
-            </a:r>
           </a:p>
         </p:txBody>
       </p:sp>
@@ -14441,96 +14927,54 @@
         </p:nvSpPr>
         <p:spPr>
           <a:xfrm>
-            <a:off x="1508760" y="2450592"/>
-            <a:ext cx="2834640" cy="502920"/>
-          </a:xfrm>
-          <a:prstGeom prst="rect">
-            <a:avLst/>
-          </a:prstGeom>
-          <a:noFill/>
-        </p:spPr>
-        <p:txBody>
-          <a:bodyPr wrap="square" anchor="ctr" lIns="0" rIns="0" tIns="0" bIns="0">
-            <a:spAutoFit/>
-          </a:bodyPr>
-          <a:lstStyle/>
-          <a:p>
-            <a:pPr algn="l">
-              <a:lnSpc>
-                <a:spcPct val="120000"/>
-              </a:lnSpc>
-            </a:pPr>
-            <a:r>
-              <a:rPr sz="1500" b="1" lang="ko-KR">
-                <a:solidFill>
-                  <a:srgbClr val="101623"/>
-                </a:solidFill>
-                <a:latin typeface="맑은 고딕"/>
-                <a:ea typeface="맑은 고딕"/>
-              </a:rPr>
-              <a:t>CI 파이프라인</a:t>
-            </a:r>
-          </a:p>
-        </p:txBody>
-      </p:sp>
-      <p:sp>
-        <p:nvSpPr>
-          <p:cNvPr id="9" name="TextBox 8"/>
-          <p:cNvSpPr txBox="1"/>
-          <p:nvPr/>
-        </p:nvSpPr>
-        <p:spPr>
-          <a:xfrm>
-            <a:off x="4572000" y="2468880"/>
-            <a:ext cx="6675120" cy="502920"/>
-          </a:xfrm>
-          <a:prstGeom prst="rect">
-            <a:avLst/>
-          </a:prstGeom>
-          <a:noFill/>
-        </p:spPr>
-        <p:txBody>
-          <a:bodyPr wrap="square" anchor="ctr" lIns="0" rIns="0" tIns="0" bIns="0">
-            <a:spAutoFit/>
-          </a:bodyPr>
-          <a:lstStyle/>
-          <a:p>
-            <a:pPr algn="l">
-              <a:lnSpc>
-                <a:spcPct val="120000"/>
-              </a:lnSpc>
-            </a:pPr>
-            <a:r>
-              <a:rPr sz="1300" b="0" lang="ko-KR">
-                <a:solidFill>
-                  <a:srgbClr val="5F6B7F"/>
-                </a:solidFill>
-                <a:latin typeface="맑은 고딕"/>
-                <a:ea typeface="맑은 고딕"/>
-              </a:rPr>
-              <a:t>PR마다 세 앱의 타입체크·린트·테스트 자동 검증</a:t>
-            </a:r>
-          </a:p>
-        </p:txBody>
-      </p:sp>
-      <p:sp>
-        <p:nvSpPr>
-          <p:cNvPr id="10" name="Rounded Rectangle 9"/>
+            <a:off x="1097280" y="2880360"/>
+            <a:ext cx="4480560" cy="731520"/>
+          </a:xfrm>
+          <a:prstGeom prst="rect">
+            <a:avLst/>
+          </a:prstGeom>
+          <a:noFill/>
+        </p:spPr>
+        <p:txBody>
+          <a:bodyPr wrap="square" anchor="t" lIns="0" rIns="0" tIns="0" bIns="0">
+            <a:spAutoFit/>
+          </a:bodyPr>
+          <a:lstStyle/>
+          <a:p>
+            <a:pPr algn="l">
+              <a:lnSpc>
+                <a:spcPct val="140000"/>
+              </a:lnSpc>
+            </a:pPr>
+            <a:r>
+              <a:rPr sz="1250" b="0" lang="ko-KR">
+                <a:solidFill>
+                  <a:srgbClr val="2C3646"/>
+                </a:solidFill>
+                <a:latin typeface="맑은 고딕"/>
+                <a:ea typeface="맑은 고딕"/>
+              </a:rPr>
+              <a:t>모든 통신을 한 파일(lib/api.ts)로 모아 — 저장 방식이 바뀌어도 고칠 곳이 한 곳</a:t>
+            </a:r>
+          </a:p>
+        </p:txBody>
+      </p:sp>
+      <p:sp>
+        <p:nvSpPr>
+          <p:cNvPr id="9" name="Oval 8"/>
           <p:cNvSpPr/>
           <p:nvPr/>
         </p:nvSpPr>
         <p:spPr>
           <a:xfrm>
-            <a:off x="822960" y="3246120"/>
-            <a:ext cx="457200" cy="457200"/>
-          </a:xfrm>
-          <a:prstGeom prst="roundRect">
-            <a:avLst>
-              <a:gd name="adj" fmla="val 50000"/>
-            </a:avLst>
+            <a:off x="822960" y="3822192"/>
+            <a:ext cx="128016" cy="128016"/>
+          </a:xfrm>
+          <a:prstGeom prst="ellipse">
+            <a:avLst/>
           </a:prstGeom>
           <a:solidFill>
-            <a:srgbClr val="4F46E5"/>
+            <a:srgbClr val="15803D"/>
           </a:solidFill>
           <a:ln>
             <a:noFill/>
@@ -14552,19 +14996,49 @@
           </a:fontRef>
         </p:style>
         <p:txBody>
-          <a:bodyPr rtlCol="0" anchor="ctr" wrap="none" lIns="25400" rIns="25400"/>
+          <a:bodyPr rtlCol="0" anchor="ctr"/>
           <a:lstStyle/>
           <a:p>
             <a:pPr algn="ctr"/>
-            <a:r>
-              <a:rPr sz="1400" b="1" lang="ko-KR">
-                <a:solidFill>
-                  <a:srgbClr val="FFFFFF"/>
-                </a:solidFill>
-                <a:latin typeface="맑은 고딕"/>
-                <a:ea typeface="맑은 고딕"/>
-              </a:rPr>
-              <a:t>3</a:t>
+          </a:p>
+        </p:txBody>
+      </p:sp>
+      <p:sp>
+        <p:nvSpPr>
+          <p:cNvPr id="10" name="TextBox 9"/>
+          <p:cNvSpPr txBox="1"/>
+          <p:nvPr/>
+        </p:nvSpPr>
+        <p:spPr>
+          <a:xfrm>
+            <a:off x="1097280" y="3749040"/>
+            <a:ext cx="4480560" cy="731520"/>
+          </a:xfrm>
+          <a:prstGeom prst="rect">
+            <a:avLst/>
+          </a:prstGeom>
+          <a:noFill/>
+        </p:spPr>
+        <p:txBody>
+          <a:bodyPr wrap="square" anchor="t" lIns="0" rIns="0" tIns="0" bIns="0">
+            <a:spAutoFit/>
+          </a:bodyPr>
+          <a:lstStyle/>
+          <a:p>
+            <a:pPr algn="l">
+              <a:lnSpc>
+                <a:spcPct val="140000"/>
+              </a:lnSpc>
+            </a:pPr>
+            <a:r>
+              <a:rPr sz="1250" b="0" lang="ko-KR">
+                <a:solidFill>
+                  <a:srgbClr val="2C3646"/>
+                </a:solidFill>
+                <a:latin typeface="맑은 고딕"/>
+                <a:ea typeface="맑은 고딕"/>
+              </a:rPr>
+              <a:t>한계를 문서에 그대로 적어 둠 — 모르는 것과 알고 미룬 것은 다르다</a:t>
             </a:r>
           </a:p>
         </p:txBody>
@@ -14577,16 +15051,16 @@
         </p:nvSpPr>
         <p:spPr>
           <a:xfrm>
-            <a:off x="1508760" y="3227832"/>
-            <a:ext cx="2834640" cy="502920"/>
-          </a:xfrm>
-          <a:prstGeom prst="rect">
-            <a:avLst/>
-          </a:prstGeom>
-          <a:noFill/>
-        </p:spPr>
-        <p:txBody>
-          <a:bodyPr wrap="square" anchor="ctr" lIns="0" rIns="0" tIns="0" bIns="0">
+            <a:off x="6309360" y="1554480"/>
+            <a:ext cx="4846320" cy="365760"/>
+          </a:xfrm>
+          <a:prstGeom prst="rect">
+            <a:avLst/>
+          </a:prstGeom>
+          <a:noFill/>
+        </p:spPr>
+        <p:txBody>
+          <a:bodyPr wrap="square" anchor="t" lIns="0" rIns="0" tIns="0" bIns="0">
             <a:spAutoFit/>
           </a:bodyPr>
           <a:lstStyle/>
@@ -14599,74 +15073,32 @@
             <a:r>
               <a:rPr sz="1500" b="1" lang="ko-KR">
                 <a:solidFill>
-                  <a:srgbClr val="101623"/>
-                </a:solidFill>
-                <a:latin typeface="맑은 고딕"/>
-                <a:ea typeface="맑은 고딕"/>
-              </a:rPr>
-              <a:t>보안 강화</a:t>
-            </a:r>
-          </a:p>
-        </p:txBody>
-      </p:sp>
-      <p:sp>
-        <p:nvSpPr>
-          <p:cNvPr id="12" name="TextBox 11"/>
-          <p:cNvSpPr txBox="1"/>
-          <p:nvPr/>
-        </p:nvSpPr>
-        <p:spPr>
-          <a:xfrm>
-            <a:off x="4572000" y="3246120"/>
-            <a:ext cx="6675120" cy="502920"/>
-          </a:xfrm>
-          <a:prstGeom prst="rect">
-            <a:avLst/>
-          </a:prstGeom>
-          <a:noFill/>
-        </p:spPr>
-        <p:txBody>
-          <a:bodyPr wrap="square" anchor="ctr" lIns="0" rIns="0" tIns="0" bIns="0">
-            <a:spAutoFit/>
-          </a:bodyPr>
-          <a:lstStyle/>
-          <a:p>
-            <a:pPr algn="l">
-              <a:lnSpc>
-                <a:spcPct val="120000"/>
-              </a:lnSpc>
-            </a:pPr>
-            <a:r>
-              <a:rPr sz="1300" b="0" lang="ko-KR">
-                <a:solidFill>
-                  <a:srgbClr val="5F6B7F"/>
-                </a:solidFill>
-                <a:latin typeface="맑은 고딕"/>
-                <a:ea typeface="맑은 고딕"/>
-              </a:rPr>
-              <a:t>Rate limiting, 보안 헤더, 입력 검증 스키마</a:t>
-            </a:r>
-          </a:p>
-        </p:txBody>
-      </p:sp>
-      <p:sp>
-        <p:nvSpPr>
-          <p:cNvPr id="13" name="Rounded Rectangle 12"/>
+                  <a:srgbClr val="B42318"/>
+                </a:solidFill>
+                <a:latin typeface="맑은 고딕"/>
+                <a:ea typeface="맑은 고딕"/>
+              </a:rPr>
+              <a:t>아쉬운 점</a:t>
+            </a:r>
+          </a:p>
+        </p:txBody>
+      </p:sp>
+      <p:sp>
+        <p:nvSpPr>
+          <p:cNvPr id="12" name="Oval 11"/>
           <p:cNvSpPr/>
           <p:nvPr/>
         </p:nvSpPr>
         <p:spPr>
           <a:xfrm>
-            <a:off x="822960" y="4023360"/>
-            <a:ext cx="457200" cy="457200"/>
-          </a:xfrm>
-          <a:prstGeom prst="roundRect">
-            <a:avLst>
-              <a:gd name="adj" fmla="val 50000"/>
-            </a:avLst>
+            <a:off x="6309360" y="2084832"/>
+            <a:ext cx="128016" cy="128016"/>
+          </a:xfrm>
+          <a:prstGeom prst="ellipse">
+            <a:avLst/>
           </a:prstGeom>
           <a:solidFill>
-            <a:srgbClr val="4F46E5"/>
+            <a:srgbClr val="B42318"/>
           </a:solidFill>
           <a:ln>
             <a:noFill/>
@@ -14688,121 +15120,69 @@
           </a:fontRef>
         </p:style>
         <p:txBody>
-          <a:bodyPr rtlCol="0" anchor="ctr" wrap="none" lIns="25400" rIns="25400"/>
+          <a:bodyPr rtlCol="0" anchor="ctr"/>
           <a:lstStyle/>
           <a:p>
             <a:pPr algn="ctr"/>
-            <a:r>
-              <a:rPr sz="1400" b="1" lang="ko-KR">
-                <a:solidFill>
-                  <a:srgbClr val="FFFFFF"/>
-                </a:solidFill>
-                <a:latin typeface="맑은 고딕"/>
-                <a:ea typeface="맑은 고딕"/>
-              </a:rPr>
-              <a:t>4</a:t>
-            </a:r>
-          </a:p>
-        </p:txBody>
-      </p:sp>
-      <p:sp>
-        <p:nvSpPr>
-          <p:cNvPr id="14" name="TextBox 13"/>
-          <p:cNvSpPr txBox="1"/>
-          <p:nvPr/>
-        </p:nvSpPr>
-        <p:spPr>
-          <a:xfrm>
-            <a:off x="1508760" y="4005072"/>
-            <a:ext cx="2834640" cy="502920"/>
-          </a:xfrm>
-          <a:prstGeom prst="rect">
-            <a:avLst/>
-          </a:prstGeom>
-          <a:noFill/>
-        </p:spPr>
-        <p:txBody>
-          <a:bodyPr wrap="square" anchor="ctr" lIns="0" rIns="0" tIns="0" bIns="0">
-            <a:spAutoFit/>
-          </a:bodyPr>
-          <a:lstStyle/>
-          <a:p>
-            <a:pPr algn="l">
-              <a:lnSpc>
-                <a:spcPct val="120000"/>
-              </a:lnSpc>
-            </a:pPr>
-            <a:r>
-              <a:rPr sz="1500" b="1" lang="ko-KR">
-                <a:solidFill>
-                  <a:srgbClr val="101623"/>
-                </a:solidFill>
-                <a:latin typeface="맑은 고딕"/>
-                <a:ea typeface="맑은 고딕"/>
-              </a:rPr>
-              <a:t>운영 감사 로그</a:t>
-            </a:r>
-          </a:p>
-        </p:txBody>
-      </p:sp>
-      <p:sp>
-        <p:nvSpPr>
-          <p:cNvPr id="15" name="TextBox 14"/>
-          <p:cNvSpPr txBox="1"/>
-          <p:nvPr/>
-        </p:nvSpPr>
-        <p:spPr>
-          <a:xfrm>
-            <a:off x="4572000" y="4023360"/>
-            <a:ext cx="6675120" cy="502920"/>
-          </a:xfrm>
-          <a:prstGeom prst="rect">
-            <a:avLst/>
-          </a:prstGeom>
-          <a:noFill/>
-        </p:spPr>
-        <p:txBody>
-          <a:bodyPr wrap="square" anchor="ctr" lIns="0" rIns="0" tIns="0" bIns="0">
-            <a:spAutoFit/>
-          </a:bodyPr>
-          <a:lstStyle/>
-          <a:p>
-            <a:pPr algn="l">
-              <a:lnSpc>
-                <a:spcPct val="120000"/>
-              </a:lnSpc>
-            </a:pPr>
-            <a:r>
-              <a:rPr sz="1300" b="0" lang="ko-KR">
-                <a:solidFill>
-                  <a:srgbClr val="5F6B7F"/>
-                </a:solidFill>
-                <a:latin typeface="맑은 고딕"/>
-                <a:ea typeface="맑은 고딕"/>
-              </a:rPr>
-              <a:t>관리자가 무엇을 했는지 추적할 수 있게</a:t>
-            </a:r>
-          </a:p>
-        </p:txBody>
-      </p:sp>
-      <p:sp>
-        <p:nvSpPr>
-          <p:cNvPr id="16" name="Rounded Rectangle 15"/>
+          </a:p>
+        </p:txBody>
+      </p:sp>
+      <p:sp>
+        <p:nvSpPr>
+          <p:cNvPr id="13" name="TextBox 12"/>
+          <p:cNvSpPr txBox="1"/>
+          <p:nvPr/>
+        </p:nvSpPr>
+        <p:spPr>
+          <a:xfrm>
+            <a:off x="6583680" y="2011680"/>
+            <a:ext cx="4572000" cy="731520"/>
+          </a:xfrm>
+          <a:prstGeom prst="rect">
+            <a:avLst/>
+          </a:prstGeom>
+          <a:noFill/>
+        </p:spPr>
+        <p:txBody>
+          <a:bodyPr wrap="square" anchor="t" lIns="0" rIns="0" tIns="0" bIns="0">
+            <a:spAutoFit/>
+          </a:bodyPr>
+          <a:lstStyle/>
+          <a:p>
+            <a:pPr algn="l">
+              <a:lnSpc>
+                <a:spcPct val="140000"/>
+              </a:lnSpc>
+            </a:pPr>
+            <a:r>
+              <a:rPr sz="1250" b="0" lang="ko-KR">
+                <a:solidFill>
+                  <a:srgbClr val="2C3646"/>
+                </a:solidFill>
+                <a:latin typeface="맑은 고딕"/>
+                <a:ea typeface="맑은 고딕"/>
+              </a:rPr>
+              <a:t>자동 검사를 늦게 깖 — 테스트를 170건 넘게 만들고도 한동안 손으로 실행</a:t>
+            </a:r>
+          </a:p>
+        </p:txBody>
+      </p:sp>
+      <p:sp>
+        <p:nvSpPr>
+          <p:cNvPr id="14" name="Oval 13"/>
           <p:cNvSpPr/>
           <p:nvPr/>
         </p:nvSpPr>
         <p:spPr>
           <a:xfrm>
-            <a:off x="822960" y="4800600"/>
-            <a:ext cx="457200" cy="457200"/>
-          </a:xfrm>
-          <a:prstGeom prst="roundRect">
-            <a:avLst>
-              <a:gd name="adj" fmla="val 50000"/>
-            </a:avLst>
+            <a:off x="6309360" y="2953512"/>
+            <a:ext cx="128016" cy="128016"/>
+          </a:xfrm>
+          <a:prstGeom prst="ellipse">
+            <a:avLst/>
           </a:prstGeom>
           <a:solidFill>
-            <a:srgbClr val="4F46E5"/>
+            <a:srgbClr val="B42318"/>
           </a:solidFill>
           <a:ln>
             <a:noFill/>
@@ -14824,20 +15204,94 @@
           </a:fontRef>
         </p:style>
         <p:txBody>
-          <a:bodyPr rtlCol="0" anchor="ctr" wrap="none" lIns="25400" rIns="25400"/>
+          <a:bodyPr rtlCol="0" anchor="ctr"/>
           <a:lstStyle/>
           <a:p>
             <a:pPr algn="ctr"/>
-            <a:r>
-              <a:rPr sz="1400" b="1" lang="ko-KR">
-                <a:solidFill>
-                  <a:srgbClr val="FFFFFF"/>
-                </a:solidFill>
-                <a:latin typeface="맑은 고딕"/>
-                <a:ea typeface="맑은 고딕"/>
-              </a:rPr>
-              <a:t>5</a:t>
-            </a:r>
+          </a:p>
+        </p:txBody>
+      </p:sp>
+      <p:sp>
+        <p:nvSpPr>
+          <p:cNvPr id="15" name="TextBox 14"/>
+          <p:cNvSpPr txBox="1"/>
+          <p:nvPr/>
+        </p:nvSpPr>
+        <p:spPr>
+          <a:xfrm>
+            <a:off x="6583680" y="2880360"/>
+            <a:ext cx="4572000" cy="731520"/>
+          </a:xfrm>
+          <a:prstGeom prst="rect">
+            <a:avLst/>
+          </a:prstGeom>
+          <a:noFill/>
+        </p:spPr>
+        <p:txBody>
+          <a:bodyPr wrap="square" anchor="t" lIns="0" rIns="0" tIns="0" bIns="0">
+            <a:spAutoFit/>
+          </a:bodyPr>
+          <a:lstStyle/>
+          <a:p>
+            <a:pPr algn="l">
+              <a:lnSpc>
+                <a:spcPct val="140000"/>
+              </a:lnSpc>
+            </a:pPr>
+            <a:r>
+              <a:rPr sz="1250" b="0" lang="ko-KR">
+                <a:solidFill>
+                  <a:srgbClr val="2C3646"/>
+                </a:solidFill>
+                <a:latin typeface="맑은 고딕"/>
+                <a:ea typeface="맑은 고딕"/>
+              </a:rPr>
+              <a:t>일부 코드 파일이 비대해짐 — 초반에 나눴다면 지금 분할 비용이 없었을 것</a:t>
+            </a:r>
+          </a:p>
+        </p:txBody>
+      </p:sp>
+      <p:sp>
+        <p:nvSpPr>
+          <p:cNvPr id="16" name="Oval 15"/>
+          <p:cNvSpPr/>
+          <p:nvPr/>
+        </p:nvSpPr>
+        <p:spPr>
+          <a:xfrm>
+            <a:off x="6309360" y="3822192"/>
+            <a:ext cx="128016" cy="128016"/>
+          </a:xfrm>
+          <a:prstGeom prst="ellipse">
+            <a:avLst/>
+          </a:prstGeom>
+          <a:solidFill>
+            <a:srgbClr val="B42318"/>
+          </a:solidFill>
+          <a:ln>
+            <a:noFill/>
+          </a:ln>
+          <a:effectLst/>
+        </p:spPr>
+        <p:style>
+          <a:lnRef idx="1">
+            <a:schemeClr val="accent1"/>
+          </a:lnRef>
+          <a:fillRef idx="3">
+            <a:schemeClr val="accent1"/>
+          </a:fillRef>
+          <a:effectRef idx="2">
+            <a:schemeClr val="accent1"/>
+          </a:effectRef>
+          <a:fontRef idx="minor">
+            <a:schemeClr val="lt1"/>
+          </a:fontRef>
+        </p:style>
+        <p:txBody>
+          <a:bodyPr rtlCol="0" anchor="ctr"/>
+          <a:lstStyle/>
+          <a:p>
+            <a:pPr algn="ctr"/>
           </a:p>
         </p:txBody>
       </p:sp>
@@ -14849,34 +15303,34 @@
         </p:nvSpPr>
         <p:spPr>
           <a:xfrm>
-            <a:off x="1508760" y="4782312"/>
-            <a:ext cx="2834640" cy="502920"/>
-          </a:xfrm>
-          <a:prstGeom prst="rect">
-            <a:avLst/>
-          </a:prstGeom>
-          <a:noFill/>
-        </p:spPr>
-        <p:txBody>
-          <a:bodyPr wrap="square" anchor="ctr" lIns="0" rIns="0" tIns="0" bIns="0">
-            <a:spAutoFit/>
-          </a:bodyPr>
-          <a:lstStyle/>
-          <a:p>
-            <a:pPr algn="l">
-              <a:lnSpc>
-                <a:spcPct val="120000"/>
-              </a:lnSpc>
-            </a:pPr>
-            <a:r>
-              <a:rPr sz="1500" b="1" lang="ko-KR">
-                <a:solidFill>
-                  <a:srgbClr val="101623"/>
-                </a:solidFill>
-                <a:latin typeface="맑은 고딕"/>
-                <a:ea typeface="맑은 고딕"/>
-              </a:rPr>
-              <a:t>접근성 · 성능</a:t>
+            <a:off x="6583680" y="3749040"/>
+            <a:ext cx="4572000" cy="731520"/>
+          </a:xfrm>
+          <a:prstGeom prst="rect">
+            <a:avLst/>
+          </a:prstGeom>
+          <a:noFill/>
+        </p:spPr>
+        <p:txBody>
+          <a:bodyPr wrap="square" anchor="t" lIns="0" rIns="0" tIns="0" bIns="0">
+            <a:spAutoFit/>
+          </a:bodyPr>
+          <a:lstStyle/>
+          <a:p>
+            <a:pPr algn="l">
+              <a:lnSpc>
+                <a:spcPct val="140000"/>
+              </a:lnSpc>
+            </a:pPr>
+            <a:r>
+              <a:rPr sz="1250" b="0" lang="ko-KR">
+                <a:solidFill>
+                  <a:srgbClr val="2C3646"/>
+                </a:solidFill>
+                <a:latin typeface="맑은 고딕"/>
+                <a:ea typeface="맑은 고딕"/>
+              </a:rPr>
+              <a:t>성능·접근성을 측정한 적이 없음 — 기능이 안정된 지금이 잴 시점</a:t>
             </a:r>
           </a:p>
         </p:txBody>
@@ -14884,46 +15338,6 @@
       <p:sp>
         <p:nvSpPr>
           <p:cNvPr id="18" name="TextBox 17"/>
-          <p:cNvSpPr txBox="1"/>
-          <p:nvPr/>
-        </p:nvSpPr>
-        <p:spPr>
-          <a:xfrm>
-            <a:off x="4572000" y="4800600"/>
-            <a:ext cx="6675120" cy="502920"/>
-          </a:xfrm>
-          <a:prstGeom prst="rect">
-            <a:avLst/>
-          </a:prstGeom>
-          <a:noFill/>
-        </p:spPr>
-        <p:txBody>
-          <a:bodyPr wrap="square" anchor="ctr" lIns="0" rIns="0" tIns="0" bIns="0">
-            <a:spAutoFit/>
-          </a:bodyPr>
-          <a:lstStyle/>
-          <a:p>
-            <a:pPr algn="l">
-              <a:lnSpc>
-                <a:spcPct val="120000"/>
-              </a:lnSpc>
-            </a:pPr>
-            <a:r>
-              <a:rPr sz="1300" b="0" lang="ko-KR">
-                <a:solidFill>
-                  <a:srgbClr val="5F6B7F"/>
-                </a:solidFill>
-                <a:latin typeface="맑은 고딕"/>
-                <a:ea typeface="맑은 고딕"/>
-              </a:rPr>
-              <a:t>기능이 안정된 지금, 기준선을 측정하고 개선</a:t>
-            </a:r>
-          </a:p>
-        </p:txBody>
-      </p:sp>
-      <p:sp>
-        <p:nvSpPr>
-          <p:cNvPr id="19" name="TextBox 18"/>
           <p:cNvSpPr txBox="1"/>
           <p:nvPr/>
         </p:nvSpPr>
@@ -14963,7 +15377,7 @@
       </p:sp>
       <p:sp>
         <p:nvSpPr>
-          <p:cNvPr id="20" name="TextBox 19"/>
+          <p:cNvPr id="19" name="TextBox 18"/>
           <p:cNvSpPr txBox="1"/>
           <p:nvPr/>
         </p:nvSpPr>
@@ -15010,6 +15424,872 @@
 </file>
 
 <file path=ppt/slides/slide23.xml><?xml version="1.0" encoding="utf-8"?>
+<p:sld xmlns:a="http://schemas.openxmlformats.org/drawingml/2006/main" xmlns:p="http://schemas.openxmlformats.org/presentationml/2006/main" xmlns:r="http://schemas.openxmlformats.org/officeDocument/2006/relationships">
+  <p:cSld>
+    <p:bg>
+      <p:bgPr>
+        <a:solidFill>
+          <a:srgbClr val="FFFFFF"/>
+        </a:solidFill>
+        <a:effectLst/>
+      </p:bgPr>
+    </p:bg>
+    <p:spTree>
+      <p:nvGrpSpPr>
+        <p:cNvPr id="1" name=""/>
+        <p:cNvGrpSpPr/>
+        <p:nvPr/>
+      </p:nvGrpSpPr>
+      <p:grpSpPr/>
+      <p:sp>
+        <p:nvSpPr>
+          <p:cNvPr id="2" name="TextBox 1"/>
+          <p:cNvSpPr txBox="1"/>
+          <p:nvPr/>
+        </p:nvSpPr>
+        <p:spPr>
+          <a:xfrm>
+            <a:off x="822960" y="457200"/>
+            <a:ext cx="8229600" cy="365760"/>
+          </a:xfrm>
+          <a:prstGeom prst="rect">
+            <a:avLst/>
+          </a:prstGeom>
+          <a:noFill/>
+        </p:spPr>
+        <p:txBody>
+          <a:bodyPr wrap="square" anchor="t" lIns="0" rIns="0" tIns="0" bIns="0">
+            <a:spAutoFit/>
+          </a:bodyPr>
+          <a:lstStyle/>
+          <a:p>
+            <a:pPr algn="l">
+              <a:lnSpc>
+                <a:spcPct val="120000"/>
+              </a:lnSpc>
+            </a:pPr>
+            <a:r>
+              <a:rPr sz="1300" b="1" lang="ko-KR">
+                <a:solidFill>
+                  <a:srgbClr val="4F46E5"/>
+                </a:solidFill>
+                <a:latin typeface="맑은 고딕"/>
+                <a:ea typeface="맑은 고딕"/>
+              </a:rPr>
+              <a:t>07 · 다음 계획</a:t>
+            </a:r>
+          </a:p>
+        </p:txBody>
+      </p:sp>
+      <p:sp>
+        <p:nvSpPr>
+          <p:cNvPr id="3" name="TextBox 2"/>
+          <p:cNvSpPr txBox="1"/>
+          <p:nvPr/>
+        </p:nvSpPr>
+        <p:spPr>
+          <a:xfrm>
+            <a:off x="822960" y="777240"/>
+            <a:ext cx="10058400" cy="640080"/>
+          </a:xfrm>
+          <a:prstGeom prst="rect">
+            <a:avLst/>
+          </a:prstGeom>
+          <a:noFill/>
+        </p:spPr>
+        <p:txBody>
+          <a:bodyPr wrap="square" anchor="t" lIns="0" rIns="0" tIns="0" bIns="0">
+            <a:spAutoFit/>
+          </a:bodyPr>
+          <a:lstStyle/>
+          <a:p>
+            <a:pPr algn="l">
+              <a:lnSpc>
+                <a:spcPct val="120000"/>
+              </a:lnSpc>
+            </a:pPr>
+            <a:r>
+              <a:rPr sz="2600" b="1" lang="ko-KR">
+                <a:solidFill>
+                  <a:srgbClr val="101623"/>
+                </a:solidFill>
+                <a:latin typeface="맑은 고딕"/>
+                <a:ea typeface="맑은 고딕"/>
+              </a:rPr>
+              <a:t>앞으로의 방향</a:t>
+            </a:r>
+          </a:p>
+        </p:txBody>
+      </p:sp>
+      <p:sp>
+        <p:nvSpPr>
+          <p:cNvPr id="4" name="Rounded Rectangle 3"/>
+          <p:cNvSpPr/>
+          <p:nvPr/>
+        </p:nvSpPr>
+        <p:spPr>
+          <a:xfrm>
+            <a:off x="822960" y="1691640"/>
+            <a:ext cx="457200" cy="457200"/>
+          </a:xfrm>
+          <a:prstGeom prst="roundRect">
+            <a:avLst>
+              <a:gd name="adj" fmla="val 50000"/>
+            </a:avLst>
+          </a:prstGeom>
+          <a:solidFill>
+            <a:srgbClr val="4F46E5"/>
+          </a:solidFill>
+          <a:ln>
+            <a:noFill/>
+          </a:ln>
+          <a:effectLst/>
+        </p:spPr>
+        <p:style>
+          <a:lnRef idx="1">
+            <a:schemeClr val="accent1"/>
+          </a:lnRef>
+          <a:fillRef idx="3">
+            <a:schemeClr val="accent1"/>
+          </a:fillRef>
+          <a:effectRef idx="2">
+            <a:schemeClr val="accent1"/>
+          </a:effectRef>
+          <a:fontRef idx="minor">
+            <a:schemeClr val="lt1"/>
+          </a:fontRef>
+        </p:style>
+        <p:txBody>
+          <a:bodyPr rtlCol="0" anchor="ctr" wrap="none" lIns="25400" rIns="25400"/>
+          <a:lstStyle/>
+          <a:p>
+            <a:pPr algn="ctr"/>
+            <a:r>
+              <a:rPr sz="1400" b="1" lang="ko-KR">
+                <a:solidFill>
+                  <a:srgbClr val="FFFFFF"/>
+                </a:solidFill>
+                <a:latin typeface="맑은 고딕"/>
+                <a:ea typeface="맑은 고딕"/>
+              </a:rPr>
+              <a:t>1</a:t>
+            </a:r>
+          </a:p>
+        </p:txBody>
+      </p:sp>
+      <p:sp>
+        <p:nvSpPr>
+          <p:cNvPr id="5" name="TextBox 4"/>
+          <p:cNvSpPr txBox="1"/>
+          <p:nvPr/>
+        </p:nvSpPr>
+        <p:spPr>
+          <a:xfrm>
+            <a:off x="1508760" y="1673352"/>
+            <a:ext cx="2834640" cy="502920"/>
+          </a:xfrm>
+          <a:prstGeom prst="rect">
+            <a:avLst/>
+          </a:prstGeom>
+          <a:noFill/>
+        </p:spPr>
+        <p:txBody>
+          <a:bodyPr wrap="square" anchor="ctr" lIns="0" rIns="0" tIns="0" bIns="0">
+            <a:spAutoFit/>
+          </a:bodyPr>
+          <a:lstStyle/>
+          <a:p>
+            <a:pPr algn="l">
+              <a:lnSpc>
+                <a:spcPct val="120000"/>
+              </a:lnSpc>
+            </a:pPr>
+            <a:r>
+              <a:rPr sz="1500" b="1" lang="ko-KR">
+                <a:solidFill>
+                  <a:srgbClr val="101623"/>
+                </a:solidFill>
+                <a:latin typeface="맑은 고딕"/>
+                <a:ea typeface="맑은 고딕"/>
+              </a:rPr>
+              <a:t>라이브 서비스 공개</a:t>
+            </a:r>
+          </a:p>
+        </p:txBody>
+      </p:sp>
+      <p:sp>
+        <p:nvSpPr>
+          <p:cNvPr id="6" name="TextBox 5"/>
+          <p:cNvSpPr txBox="1"/>
+          <p:nvPr/>
+        </p:nvSpPr>
+        <p:spPr>
+          <a:xfrm>
+            <a:off x="4572000" y="1691640"/>
+            <a:ext cx="6675120" cy="502920"/>
+          </a:xfrm>
+          <a:prstGeom prst="rect">
+            <a:avLst/>
+          </a:prstGeom>
+          <a:noFill/>
+        </p:spPr>
+        <p:txBody>
+          <a:bodyPr wrap="square" anchor="ctr" lIns="0" rIns="0" tIns="0" bIns="0">
+            <a:spAutoFit/>
+          </a:bodyPr>
+          <a:lstStyle/>
+          <a:p>
+            <a:pPr algn="l">
+              <a:lnSpc>
+                <a:spcPct val="120000"/>
+              </a:lnSpc>
+            </a:pPr>
+            <a:r>
+              <a:rPr sz="1300" b="0" lang="ko-KR">
+                <a:solidFill>
+                  <a:srgbClr val="5F6B7F"/>
+                </a:solidFill>
+                <a:latin typeface="맑은 고딕"/>
+                <a:ea typeface="맑은 고딕"/>
+              </a:rPr>
+              <a:t>클라우드 서버·도메인 연결 — 배포 준비는 끝남</a:t>
+            </a:r>
+          </a:p>
+        </p:txBody>
+      </p:sp>
+      <p:sp>
+        <p:nvSpPr>
+          <p:cNvPr id="7" name="Rounded Rectangle 6"/>
+          <p:cNvSpPr/>
+          <p:nvPr/>
+        </p:nvSpPr>
+        <p:spPr>
+          <a:xfrm>
+            <a:off x="822960" y="2468880"/>
+            <a:ext cx="457200" cy="457200"/>
+          </a:xfrm>
+          <a:prstGeom prst="roundRect">
+            <a:avLst>
+              <a:gd name="adj" fmla="val 50000"/>
+            </a:avLst>
+          </a:prstGeom>
+          <a:solidFill>
+            <a:srgbClr val="4F46E5"/>
+          </a:solidFill>
+          <a:ln>
+            <a:noFill/>
+          </a:ln>
+          <a:effectLst/>
+        </p:spPr>
+        <p:style>
+          <a:lnRef idx="1">
+            <a:schemeClr val="accent1"/>
+          </a:lnRef>
+          <a:fillRef idx="3">
+            <a:schemeClr val="accent1"/>
+          </a:fillRef>
+          <a:effectRef idx="2">
+            <a:schemeClr val="accent1"/>
+          </a:effectRef>
+          <a:fontRef idx="minor">
+            <a:schemeClr val="lt1"/>
+          </a:fontRef>
+        </p:style>
+        <p:txBody>
+          <a:bodyPr rtlCol="0" anchor="ctr" wrap="none" lIns="25400" rIns="25400"/>
+          <a:lstStyle/>
+          <a:p>
+            <a:pPr algn="ctr"/>
+            <a:r>
+              <a:rPr sz="1400" b="1" lang="ko-KR">
+                <a:solidFill>
+                  <a:srgbClr val="FFFFFF"/>
+                </a:solidFill>
+                <a:latin typeface="맑은 고딕"/>
+                <a:ea typeface="맑은 고딕"/>
+              </a:rPr>
+              <a:t>2</a:t>
+            </a:r>
+          </a:p>
+        </p:txBody>
+      </p:sp>
+      <p:sp>
+        <p:nvSpPr>
+          <p:cNvPr id="8" name="TextBox 7"/>
+          <p:cNvSpPr txBox="1"/>
+          <p:nvPr/>
+        </p:nvSpPr>
+        <p:spPr>
+          <a:xfrm>
+            <a:off x="1508760" y="2450592"/>
+            <a:ext cx="2834640" cy="502920"/>
+          </a:xfrm>
+          <a:prstGeom prst="rect">
+            <a:avLst/>
+          </a:prstGeom>
+          <a:noFill/>
+        </p:spPr>
+        <p:txBody>
+          <a:bodyPr wrap="square" anchor="ctr" lIns="0" rIns="0" tIns="0" bIns="0">
+            <a:spAutoFit/>
+          </a:bodyPr>
+          <a:lstStyle/>
+          <a:p>
+            <a:pPr algn="l">
+              <a:lnSpc>
+                <a:spcPct val="120000"/>
+              </a:lnSpc>
+            </a:pPr>
+            <a:r>
+              <a:rPr sz="1500" b="1" lang="ko-KR">
+                <a:solidFill>
+                  <a:srgbClr val="101623"/>
+                </a:solidFill>
+                <a:latin typeface="맑은 고딕"/>
+                <a:ea typeface="맑은 고딕"/>
+              </a:rPr>
+              <a:t>보안 강화</a:t>
+            </a:r>
+          </a:p>
+        </p:txBody>
+      </p:sp>
+      <p:sp>
+        <p:nvSpPr>
+          <p:cNvPr id="9" name="TextBox 8"/>
+          <p:cNvSpPr txBox="1"/>
+          <p:nvPr/>
+        </p:nvSpPr>
+        <p:spPr>
+          <a:xfrm>
+            <a:off x="4572000" y="2468880"/>
+            <a:ext cx="6675120" cy="502920"/>
+          </a:xfrm>
+          <a:prstGeom prst="rect">
+            <a:avLst/>
+          </a:prstGeom>
+          <a:noFill/>
+        </p:spPr>
+        <p:txBody>
+          <a:bodyPr wrap="square" anchor="ctr" lIns="0" rIns="0" tIns="0" bIns="0">
+            <a:spAutoFit/>
+          </a:bodyPr>
+          <a:lstStyle/>
+          <a:p>
+            <a:pPr algn="l">
+              <a:lnSpc>
+                <a:spcPct val="120000"/>
+              </a:lnSpc>
+            </a:pPr>
+            <a:r>
+              <a:rPr sz="1300" b="0" lang="ko-KR">
+                <a:solidFill>
+                  <a:srgbClr val="5F6B7F"/>
+                </a:solidFill>
+                <a:latin typeface="맑은 고딕"/>
+                <a:ea typeface="맑은 고딕"/>
+              </a:rPr>
+              <a:t>Rate limiting, 보안 헤더, 입력 검증 스키마</a:t>
+            </a:r>
+          </a:p>
+        </p:txBody>
+      </p:sp>
+      <p:sp>
+        <p:nvSpPr>
+          <p:cNvPr id="10" name="Rounded Rectangle 9"/>
+          <p:cNvSpPr/>
+          <p:nvPr/>
+        </p:nvSpPr>
+        <p:spPr>
+          <a:xfrm>
+            <a:off x="822960" y="3246120"/>
+            <a:ext cx="457200" cy="457200"/>
+          </a:xfrm>
+          <a:prstGeom prst="roundRect">
+            <a:avLst>
+              <a:gd name="adj" fmla="val 50000"/>
+            </a:avLst>
+          </a:prstGeom>
+          <a:solidFill>
+            <a:srgbClr val="4F46E5"/>
+          </a:solidFill>
+          <a:ln>
+            <a:noFill/>
+          </a:ln>
+          <a:effectLst/>
+        </p:spPr>
+        <p:style>
+          <a:lnRef idx="1">
+            <a:schemeClr val="accent1"/>
+          </a:lnRef>
+          <a:fillRef idx="3">
+            <a:schemeClr val="accent1"/>
+          </a:fillRef>
+          <a:effectRef idx="2">
+            <a:schemeClr val="accent1"/>
+          </a:effectRef>
+          <a:fontRef idx="minor">
+            <a:schemeClr val="lt1"/>
+          </a:fontRef>
+        </p:style>
+        <p:txBody>
+          <a:bodyPr rtlCol="0" anchor="ctr" wrap="none" lIns="25400" rIns="25400"/>
+          <a:lstStyle/>
+          <a:p>
+            <a:pPr algn="ctr"/>
+            <a:r>
+              <a:rPr sz="1400" b="1" lang="ko-KR">
+                <a:solidFill>
+                  <a:srgbClr val="FFFFFF"/>
+                </a:solidFill>
+                <a:latin typeface="맑은 고딕"/>
+                <a:ea typeface="맑은 고딕"/>
+              </a:rPr>
+              <a:t>3</a:t>
+            </a:r>
+          </a:p>
+        </p:txBody>
+      </p:sp>
+      <p:sp>
+        <p:nvSpPr>
+          <p:cNvPr id="11" name="TextBox 10"/>
+          <p:cNvSpPr txBox="1"/>
+          <p:nvPr/>
+        </p:nvSpPr>
+        <p:spPr>
+          <a:xfrm>
+            <a:off x="1508760" y="3227832"/>
+            <a:ext cx="2834640" cy="502920"/>
+          </a:xfrm>
+          <a:prstGeom prst="rect">
+            <a:avLst/>
+          </a:prstGeom>
+          <a:noFill/>
+        </p:spPr>
+        <p:txBody>
+          <a:bodyPr wrap="square" anchor="ctr" lIns="0" rIns="0" tIns="0" bIns="0">
+            <a:spAutoFit/>
+          </a:bodyPr>
+          <a:lstStyle/>
+          <a:p>
+            <a:pPr algn="l">
+              <a:lnSpc>
+                <a:spcPct val="120000"/>
+              </a:lnSpc>
+            </a:pPr>
+            <a:r>
+              <a:rPr sz="1500" b="1" lang="ko-KR">
+                <a:solidFill>
+                  <a:srgbClr val="101623"/>
+                </a:solidFill>
+                <a:latin typeface="맑은 고딕"/>
+                <a:ea typeface="맑은 고딕"/>
+              </a:rPr>
+              <a:t>운영 감사 로그</a:t>
+            </a:r>
+          </a:p>
+        </p:txBody>
+      </p:sp>
+      <p:sp>
+        <p:nvSpPr>
+          <p:cNvPr id="12" name="TextBox 11"/>
+          <p:cNvSpPr txBox="1"/>
+          <p:nvPr/>
+        </p:nvSpPr>
+        <p:spPr>
+          <a:xfrm>
+            <a:off x="4572000" y="3246120"/>
+            <a:ext cx="6675120" cy="502920"/>
+          </a:xfrm>
+          <a:prstGeom prst="rect">
+            <a:avLst/>
+          </a:prstGeom>
+          <a:noFill/>
+        </p:spPr>
+        <p:txBody>
+          <a:bodyPr wrap="square" anchor="ctr" lIns="0" rIns="0" tIns="0" bIns="0">
+            <a:spAutoFit/>
+          </a:bodyPr>
+          <a:lstStyle/>
+          <a:p>
+            <a:pPr algn="l">
+              <a:lnSpc>
+                <a:spcPct val="120000"/>
+              </a:lnSpc>
+            </a:pPr>
+            <a:r>
+              <a:rPr sz="1300" b="0" lang="ko-KR">
+                <a:solidFill>
+                  <a:srgbClr val="5F6B7F"/>
+                </a:solidFill>
+                <a:latin typeface="맑은 고딕"/>
+                <a:ea typeface="맑은 고딕"/>
+              </a:rPr>
+              <a:t>관리자가 무엇을 했는지 추적할 수 있게</a:t>
+            </a:r>
+          </a:p>
+        </p:txBody>
+      </p:sp>
+      <p:sp>
+        <p:nvSpPr>
+          <p:cNvPr id="13" name="Rounded Rectangle 12"/>
+          <p:cNvSpPr/>
+          <p:nvPr/>
+        </p:nvSpPr>
+        <p:spPr>
+          <a:xfrm>
+            <a:off x="822960" y="4023360"/>
+            <a:ext cx="457200" cy="457200"/>
+          </a:xfrm>
+          <a:prstGeom prst="roundRect">
+            <a:avLst>
+              <a:gd name="adj" fmla="val 50000"/>
+            </a:avLst>
+          </a:prstGeom>
+          <a:solidFill>
+            <a:srgbClr val="4F46E5"/>
+          </a:solidFill>
+          <a:ln>
+            <a:noFill/>
+          </a:ln>
+          <a:effectLst/>
+        </p:spPr>
+        <p:style>
+          <a:lnRef idx="1">
+            <a:schemeClr val="accent1"/>
+          </a:lnRef>
+          <a:fillRef idx="3">
+            <a:schemeClr val="accent1"/>
+          </a:fillRef>
+          <a:effectRef idx="2">
+            <a:schemeClr val="accent1"/>
+          </a:effectRef>
+          <a:fontRef idx="minor">
+            <a:schemeClr val="lt1"/>
+          </a:fontRef>
+        </p:style>
+        <p:txBody>
+          <a:bodyPr rtlCol="0" anchor="ctr" wrap="none" lIns="25400" rIns="25400"/>
+          <a:lstStyle/>
+          <a:p>
+            <a:pPr algn="ctr"/>
+            <a:r>
+              <a:rPr sz="1400" b="1" lang="ko-KR">
+                <a:solidFill>
+                  <a:srgbClr val="FFFFFF"/>
+                </a:solidFill>
+                <a:latin typeface="맑은 고딕"/>
+                <a:ea typeface="맑은 고딕"/>
+              </a:rPr>
+              <a:t>4</a:t>
+            </a:r>
+          </a:p>
+        </p:txBody>
+      </p:sp>
+      <p:sp>
+        <p:nvSpPr>
+          <p:cNvPr id="14" name="TextBox 13"/>
+          <p:cNvSpPr txBox="1"/>
+          <p:nvPr/>
+        </p:nvSpPr>
+        <p:spPr>
+          <a:xfrm>
+            <a:off x="1508760" y="4005072"/>
+            <a:ext cx="2834640" cy="502920"/>
+          </a:xfrm>
+          <a:prstGeom prst="rect">
+            <a:avLst/>
+          </a:prstGeom>
+          <a:noFill/>
+        </p:spPr>
+        <p:txBody>
+          <a:bodyPr wrap="square" anchor="ctr" lIns="0" rIns="0" tIns="0" bIns="0">
+            <a:spAutoFit/>
+          </a:bodyPr>
+          <a:lstStyle/>
+          <a:p>
+            <a:pPr algn="l">
+              <a:lnSpc>
+                <a:spcPct val="120000"/>
+              </a:lnSpc>
+            </a:pPr>
+            <a:r>
+              <a:rPr sz="1500" b="1" lang="ko-KR">
+                <a:solidFill>
+                  <a:srgbClr val="101623"/>
+                </a:solidFill>
+                <a:latin typeface="맑은 고딕"/>
+                <a:ea typeface="맑은 고딕"/>
+              </a:rPr>
+              <a:t>접근성 · 성능</a:t>
+            </a:r>
+          </a:p>
+        </p:txBody>
+      </p:sp>
+      <p:sp>
+        <p:nvSpPr>
+          <p:cNvPr id="15" name="TextBox 14"/>
+          <p:cNvSpPr txBox="1"/>
+          <p:nvPr/>
+        </p:nvSpPr>
+        <p:spPr>
+          <a:xfrm>
+            <a:off x="4572000" y="4023360"/>
+            <a:ext cx="6675120" cy="502920"/>
+          </a:xfrm>
+          <a:prstGeom prst="rect">
+            <a:avLst/>
+          </a:prstGeom>
+          <a:noFill/>
+        </p:spPr>
+        <p:txBody>
+          <a:bodyPr wrap="square" anchor="ctr" lIns="0" rIns="0" tIns="0" bIns="0">
+            <a:spAutoFit/>
+          </a:bodyPr>
+          <a:lstStyle/>
+          <a:p>
+            <a:pPr algn="l">
+              <a:lnSpc>
+                <a:spcPct val="120000"/>
+              </a:lnSpc>
+            </a:pPr>
+            <a:r>
+              <a:rPr sz="1300" b="0" lang="ko-KR">
+                <a:solidFill>
+                  <a:srgbClr val="5F6B7F"/>
+                </a:solidFill>
+                <a:latin typeface="맑은 고딕"/>
+                <a:ea typeface="맑은 고딕"/>
+              </a:rPr>
+              <a:t>기능이 안정된 지금, 기준선을 측정하고 개선</a:t>
+            </a:r>
+          </a:p>
+        </p:txBody>
+      </p:sp>
+      <p:sp>
+        <p:nvSpPr>
+          <p:cNvPr id="16" name="Rounded Rectangle 15"/>
+          <p:cNvSpPr/>
+          <p:nvPr/>
+        </p:nvSpPr>
+        <p:spPr>
+          <a:xfrm>
+            <a:off x="822960" y="4800600"/>
+            <a:ext cx="457200" cy="457200"/>
+          </a:xfrm>
+          <a:prstGeom prst="roundRect">
+            <a:avLst>
+              <a:gd name="adj" fmla="val 50000"/>
+            </a:avLst>
+          </a:prstGeom>
+          <a:solidFill>
+            <a:srgbClr val="4F46E5"/>
+          </a:solidFill>
+          <a:ln>
+            <a:noFill/>
+          </a:ln>
+          <a:effectLst/>
+        </p:spPr>
+        <p:style>
+          <a:lnRef idx="1">
+            <a:schemeClr val="accent1"/>
+          </a:lnRef>
+          <a:fillRef idx="3">
+            <a:schemeClr val="accent1"/>
+          </a:fillRef>
+          <a:effectRef idx="2">
+            <a:schemeClr val="accent1"/>
+          </a:effectRef>
+          <a:fontRef idx="minor">
+            <a:schemeClr val="lt1"/>
+          </a:fontRef>
+        </p:style>
+        <p:txBody>
+          <a:bodyPr rtlCol="0" anchor="ctr" wrap="none" lIns="25400" rIns="25400"/>
+          <a:lstStyle/>
+          <a:p>
+            <a:pPr algn="ctr"/>
+            <a:r>
+              <a:rPr sz="1400" b="1" lang="ko-KR">
+                <a:solidFill>
+                  <a:srgbClr val="FFFFFF"/>
+                </a:solidFill>
+                <a:latin typeface="맑은 고딕"/>
+                <a:ea typeface="맑은 고딕"/>
+              </a:rPr>
+              <a:t>5</a:t>
+            </a:r>
+          </a:p>
+        </p:txBody>
+      </p:sp>
+      <p:sp>
+        <p:nvSpPr>
+          <p:cNvPr id="17" name="TextBox 16"/>
+          <p:cNvSpPr txBox="1"/>
+          <p:nvPr/>
+        </p:nvSpPr>
+        <p:spPr>
+          <a:xfrm>
+            <a:off x="1508760" y="4782312"/>
+            <a:ext cx="2834640" cy="502920"/>
+          </a:xfrm>
+          <a:prstGeom prst="rect">
+            <a:avLst/>
+          </a:prstGeom>
+          <a:noFill/>
+        </p:spPr>
+        <p:txBody>
+          <a:bodyPr wrap="square" anchor="ctr" lIns="0" rIns="0" tIns="0" bIns="0">
+            <a:spAutoFit/>
+          </a:bodyPr>
+          <a:lstStyle/>
+          <a:p>
+            <a:pPr algn="l">
+              <a:lnSpc>
+                <a:spcPct val="120000"/>
+              </a:lnSpc>
+            </a:pPr>
+            <a:r>
+              <a:rPr sz="1500" b="1" lang="ko-KR">
+                <a:solidFill>
+                  <a:srgbClr val="101623"/>
+                </a:solidFill>
+                <a:latin typeface="맑은 고딕"/>
+                <a:ea typeface="맑은 고딕"/>
+              </a:rPr>
+              <a:t>영상 저장소 분리</a:t>
+            </a:r>
+          </a:p>
+        </p:txBody>
+      </p:sp>
+      <p:sp>
+        <p:nvSpPr>
+          <p:cNvPr id="18" name="TextBox 17"/>
+          <p:cNvSpPr txBox="1"/>
+          <p:nvPr/>
+        </p:nvSpPr>
+        <p:spPr>
+          <a:xfrm>
+            <a:off x="4572000" y="4800600"/>
+            <a:ext cx="6675120" cy="502920"/>
+          </a:xfrm>
+          <a:prstGeom prst="rect">
+            <a:avLst/>
+          </a:prstGeom>
+          <a:noFill/>
+        </p:spPr>
+        <p:txBody>
+          <a:bodyPr wrap="square" anchor="ctr" lIns="0" rIns="0" tIns="0" bIns="0">
+            <a:spAutoFit/>
+          </a:bodyPr>
+          <a:lstStyle/>
+          <a:p>
+            <a:pPr algn="l">
+              <a:lnSpc>
+                <a:spcPct val="120000"/>
+              </a:lnSpc>
+            </a:pPr>
+            <a:r>
+              <a:rPr sz="1300" b="0" lang="ko-KR">
+                <a:solidFill>
+                  <a:srgbClr val="5F6B7F"/>
+                </a:solidFill>
+                <a:latin typeface="맑은 고딕"/>
+                <a:ea typeface="맑은 고딕"/>
+              </a:rPr>
+              <a:t>업로드가 늘면 전용 저장소로 옮겨 서버 부담을 덜기</a:t>
+            </a:r>
+          </a:p>
+        </p:txBody>
+      </p:sp>
+      <p:sp>
+        <p:nvSpPr>
+          <p:cNvPr id="19" name="TextBox 18"/>
+          <p:cNvSpPr txBox="1"/>
+          <p:nvPr/>
+        </p:nvSpPr>
+        <p:spPr>
+          <a:xfrm>
+            <a:off x="11277295" y="6400800"/>
+            <a:ext cx="640080" cy="320040"/>
+          </a:xfrm>
+          <a:prstGeom prst="rect">
+            <a:avLst/>
+          </a:prstGeom>
+          <a:noFill/>
+        </p:spPr>
+        <p:txBody>
+          <a:bodyPr wrap="square" anchor="t" lIns="0" rIns="0" tIns="0" bIns="0">
+            <a:spAutoFit/>
+          </a:bodyPr>
+          <a:lstStyle/>
+          <a:p>
+            <a:pPr algn="r">
+              <a:lnSpc>
+                <a:spcPct val="120000"/>
+              </a:lnSpc>
+            </a:pPr>
+            <a:r>
+              <a:rPr sz="1100" b="0" lang="ko-KR">
+                <a:solidFill>
+                  <a:srgbClr val="5F6B7F"/>
+                </a:solidFill>
+                <a:latin typeface="맑은 고딕"/>
+                <a:ea typeface="맑은 고딕"/>
+              </a:rPr>
+              <a:t>23</a:t>
+            </a:r>
+          </a:p>
+        </p:txBody>
+      </p:sp>
+      <p:sp>
+        <p:nvSpPr>
+          <p:cNvPr id="20" name="TextBox 19"/>
+          <p:cNvSpPr txBox="1"/>
+          <p:nvPr/>
+        </p:nvSpPr>
+        <p:spPr>
+          <a:xfrm>
+            <a:off x="457200" y="6400800"/>
+            <a:ext cx="3657600" cy="320040"/>
+          </a:xfrm>
+          <a:prstGeom prst="rect">
+            <a:avLst/>
+          </a:prstGeom>
+          <a:noFill/>
+        </p:spPr>
+        <p:txBody>
+          <a:bodyPr wrap="square" anchor="t" lIns="0" rIns="0" tIns="0" bIns="0">
+            <a:spAutoFit/>
+          </a:bodyPr>
+          <a:lstStyle/>
+          <a:p>
+            <a:pPr algn="l">
+              <a:lnSpc>
+                <a:spcPct val="120000"/>
+              </a:lnSpc>
+            </a:pPr>
+            <a:r>
+              <a:rPr sz="1100" b="1" lang="ko-KR">
+                <a:solidFill>
+                  <a:srgbClr val="5F6B7F"/>
+                </a:solidFill>
+                <a:latin typeface="맑은 고딕"/>
+                <a:ea typeface="맑은 고딕"/>
+              </a:rPr>
+              <a:t>VidShare</a:t>
+            </a:r>
+          </a:p>
+        </p:txBody>
+      </p:sp>
+    </p:spTree>
+  </p:cSld>
+  <p:clrMapOvr>
+    <a:masterClrMapping/>
+  </p:clrMapOvr>
+</p:sld>
+</file>
+
+<file path=ppt/slides/slide24.xml><?xml version="1.0" encoding="utf-8"?>
 <p:sld xmlns:a="http://schemas.openxmlformats.org/drawingml/2006/main" xmlns:p="http://schemas.openxmlformats.org/presentationml/2006/main" xmlns:r="http://schemas.openxmlformats.org/officeDocument/2006/relationships">
   <p:cSld>
     <p:bg>
@@ -15472,7 +16752,7 @@
                 <a:latin typeface="맑은 고딕"/>
                 <a:ea typeface="맑은 고딕"/>
               </a:rPr>
-              <a:t>23</a:t>
+              <a:t>24</a:t>
             </a:r>
           </a:p>
         </p:txBody>
@@ -17793,7 +19073,7 @@
                 <a:latin typeface="맑은 고딕"/>
                 <a:ea typeface="맑은 고딕"/>
               </a:rPr>
-              <a:t>REST API·SQLite</a:t>
+              <a:t>REST API·PostgreSQL</a:t>
             </a:r>
           </a:p>
           <a:p>

</xml_diff>